<commit_message>
Clarify authorisation and enforcement boundary
</commit_message>
<xml_diff>
--- a/outputs/cordant_inntris_architecture.pptx
+++ b/outputs/cordant_inntris_architecture.pptx
@@ -2,13 +2,13 @@
 <file path=ppt/presentation.xml><?xml version="1.0" encoding="utf-8"?>
 <p:presentation xmlns:p="http://schemas.openxmlformats.org/presentationml/2006/main">
   <p:sldMasterIdLst>
-    <p:sldMasterId xmlns:r="http://schemas.openxmlformats.org/officeDocument/2006/relationships" id="2147483648" r:id="Raaa9cd1244c747ed"/>
+    <p:sldMasterId xmlns:r="http://schemas.openxmlformats.org/officeDocument/2006/relationships" id="2147483648" r:id="Ra848af1c9a5e46db"/>
   </p:sldMasterIdLst>
   <p:notesMasterIdLst>
-    <p:notesMasterId xmlns:r="http://schemas.openxmlformats.org/officeDocument/2006/relationships" r:id="Rd77c5889a506491d"/>
+    <p:notesMasterId xmlns:r="http://schemas.openxmlformats.org/officeDocument/2006/relationships" r:id="Rbdba1fa3f7b94aa1"/>
   </p:notesMasterIdLst>
   <p:sldIdLst>
-    <p:sldId xmlns:r="http://schemas.openxmlformats.org/officeDocument/2006/relationships" id="256" r:id="R0a968e33959c4654"/>
+    <p:sldId xmlns:r="http://schemas.openxmlformats.org/officeDocument/2006/relationships" id="256" r:id="Rb338a17ebf2e4994"/>
   </p:sldIdLst>
   <p:sldSz cx="12192000" cy="6858000"/>
   <p:notesSz cx="6858000" cy="9144000"/>
@@ -601,7 +601,7 @@
   </p:cSld>
   <p:clrMap bg1="lt1" tx1="dk1" bg2="lt2" tx2="dk2" accent1="accent1" accent2="accent2" accent3="accent3" accent4="accent4" accent5="accent5" accent6="accent6" hlink="hlink" folHlink="folHlink"/>
   <p:sldLayoutIdLst>
-    <p:sldLayoutId xmlns:r="http://schemas.openxmlformats.org/officeDocument/2006/relationships" id="2147483649" r:id="R82e9f80cd50c48e5"/>
+    <p:sldLayoutId xmlns:r="http://schemas.openxmlformats.org/officeDocument/2006/relationships" id="2147483649" r:id="Ra1a4542ff3454d0e"/>
   </p:sldLayoutIdLst>
   <p:txStyles>
     <p:titleStyle>
@@ -1145,7 +1145,7 @@
           <p:cNvPr id="80" name="canvas">
             <a:extLst xmlns:a="http://schemas.openxmlformats.org/drawingml/2006/main">
               <a:ext uri="{FF2B5EF4-FFF2-40B4-BE49-F238E27FC236}">
-                <a16:creationId xmlns:a16="http://schemas.microsoft.com/office/drawing/2014/main" id="{07523A9C-A15C-4A13-9DC5-3206711F624F}"/>
+                <a16:creationId xmlns:a16="http://schemas.microsoft.com/office/drawing/2014/main" id="{5A7FE704-0049-422D-9D29-587096EC1FCA}"/>
               </a:ext>
             </a:extLst>
           </p:cNvPr>
@@ -1178,7 +1178,7 @@
           <p:cNvPr id="2" name="eyebrow">
             <a:extLst xmlns:a="http://schemas.openxmlformats.org/drawingml/2006/main">
               <a:ext uri="{FF2B5EF4-FFF2-40B4-BE49-F238E27FC236}">
-                <a16:creationId xmlns:a16="http://schemas.microsoft.com/office/drawing/2014/main" id="{B32C3A3C-E235-4C3E-9316-FEA2CEBB405C}"/>
+                <a16:creationId xmlns:a16="http://schemas.microsoft.com/office/drawing/2014/main" id="{6E8124C3-7E17-41C5-921F-601175850AE6}"/>
               </a:ext>
             </a:extLst>
           </p:cNvPr>
@@ -1223,32 +1223,32 @@
           <p:cNvPr id="3" name="headline">
             <a:extLst xmlns:a="http://schemas.openxmlformats.org/drawingml/2006/main">
               <a:ext uri="{FF2B5EF4-FFF2-40B4-BE49-F238E27FC236}">
-                <a16:creationId xmlns:a16="http://schemas.microsoft.com/office/drawing/2014/main" id="{9EE48D60-E481-4E64-9548-0DE638F7C27C}"/>
-              </a:ext>
-            </a:extLst>
-          </p:cNvPr>
-          <p:cNvSpPr>
-            <a:spLocks xmlns:a="http://schemas.openxmlformats.org/drawingml/2006/main" noGrp="1"/>
-          </p:cNvSpPr>
-          <p:nvPr/>
-        </p:nvSpPr>
-        <p:spPr>
-          <a:xfrm xmlns:a="http://schemas.openxmlformats.org/drawingml/2006/main">
-            <a:off x="495300" y="457200"/>
-            <a:ext cx="11201400" cy="476250"/>
-          </a:xfrm>
-          <a:prstGeom xmlns:a="http://schemas.openxmlformats.org/drawingml/2006/main" prst="rect">
-            <a:avLst/>
-          </a:prstGeom>
-        </p:spPr>
-        <p:txBody>
-          <a:bodyPr xmlns:a="http://schemas.openxmlformats.org/drawingml/2006/main" lIns="0" tIns="0" rIns="0" bIns="0" anchor="ctr">
-            <a:normAutofit fontScale="100000"/>
+                <a16:creationId xmlns:a16="http://schemas.microsoft.com/office/drawing/2014/main" id="{CD784A14-1F48-478D-9509-212ECE39E07A}"/>
+              </a:ext>
+            </a:extLst>
+          </p:cNvPr>
+          <p:cNvSpPr>
+            <a:spLocks xmlns:a="http://schemas.openxmlformats.org/drawingml/2006/main" noGrp="1"/>
+          </p:cNvSpPr>
+          <p:nvPr/>
+        </p:nvSpPr>
+        <p:spPr>
+          <a:xfrm xmlns:a="http://schemas.openxmlformats.org/drawingml/2006/main">
+            <a:off x="495300" y="409575"/>
+            <a:ext cx="11201400" cy="685800"/>
+          </a:xfrm>
+          <a:prstGeom xmlns:a="http://schemas.openxmlformats.org/drawingml/2006/main" prst="rect">
+            <a:avLst/>
+          </a:prstGeom>
+        </p:spPr>
+        <p:txBody>
+          <a:bodyPr xmlns:a="http://schemas.openxmlformats.org/drawingml/2006/main" lIns="0" tIns="0" rIns="0" bIns="0" anchor="ctr">
+            <a:normAutofit fontScale="85714"/>
           </a:bodyPr>
           <a:lstStyle xmlns:a="http://schemas.openxmlformats.org/drawingml/2006/main"/>
           <a:p xmlns:a="http://schemas.openxmlformats.org/drawingml/2006/main">
             <a:pPr algn="l">
-              <a:defRPr sz="2850" b="1">
+              <a:defRPr sz="2625" b="1">
                 <a:solidFill>
                   <a:srgbClr val="0B0F14"/>
                 </a:solidFill>
@@ -1258,7 +1258,8 @@
               </a:defRPr>
             </a:pPr>
             <a:r>
-              <a:t>Inntris controls execution. Inntris Verify checks the evidence.</a:t>
+              <a:t>Inntris authorises the action. The executor enforces it.
+Inntris Verify checks the evidence.</a:t>
             </a:r>
           </a:p>
         </p:txBody>
@@ -1268,32 +1269,32 @@
           <p:cNvPr id="4" name="subhead">
             <a:extLst xmlns:a="http://schemas.openxmlformats.org/drawingml/2006/main">
               <a:ext uri="{FF2B5EF4-FFF2-40B4-BE49-F238E27FC236}">
-                <a16:creationId xmlns:a16="http://schemas.microsoft.com/office/drawing/2014/main" id="{79E19355-9170-42FD-8F88-27AEB5B17132}"/>
-              </a:ext>
-            </a:extLst>
-          </p:cNvPr>
-          <p:cNvSpPr>
-            <a:spLocks xmlns:a="http://schemas.openxmlformats.org/drawingml/2006/main" noGrp="1"/>
-          </p:cNvSpPr>
-          <p:nvPr/>
-        </p:nvSpPr>
-        <p:spPr>
-          <a:xfrm xmlns:a="http://schemas.openxmlformats.org/drawingml/2006/main">
-            <a:off x="495300" y="1000125"/>
-            <a:ext cx="10906125" cy="257175"/>
-          </a:xfrm>
-          <a:prstGeom xmlns:a="http://schemas.openxmlformats.org/drawingml/2006/main" prst="rect">
-            <a:avLst/>
-          </a:prstGeom>
-        </p:spPr>
-        <p:txBody>
-          <a:bodyPr xmlns:a="http://schemas.openxmlformats.org/drawingml/2006/main" lIns="0" tIns="0" rIns="0" bIns="0" anchor="ctr">
-            <a:normAutofit fontScale="100000"/>
+                <a16:creationId xmlns:a16="http://schemas.microsoft.com/office/drawing/2014/main" id="{BFE5D7EF-36F4-4E1C-9108-DF9E4223BBE5}"/>
+              </a:ext>
+            </a:extLst>
+          </p:cNvPr>
+          <p:cNvSpPr>
+            <a:spLocks xmlns:a="http://schemas.openxmlformats.org/drawingml/2006/main" noGrp="1"/>
+          </p:cNvSpPr>
+          <p:nvPr/>
+        </p:nvSpPr>
+        <p:spPr>
+          <a:xfrm xmlns:a="http://schemas.openxmlformats.org/drawingml/2006/main">
+            <a:off x="495300" y="1133475"/>
+            <a:ext cx="10906125" cy="361950"/>
+          </a:xfrm>
+          <a:prstGeom xmlns:a="http://schemas.openxmlformats.org/drawingml/2006/main" prst="rect">
+            <a:avLst/>
+          </a:prstGeom>
+        </p:spPr>
+        <p:txBody>
+          <a:bodyPr xmlns:a="http://schemas.openxmlformats.org/drawingml/2006/main" lIns="0" tIns="0" rIns="0" bIns="0" anchor="ctr">
+            <a:normAutofit fontScale="98958"/>
           </a:bodyPr>
           <a:lstStyle xmlns:a="http://schemas.openxmlformats.org/drawingml/2006/main"/>
           <a:p xmlns:a="http://schemas.openxmlformats.org/drawingml/2006/main">
             <a:pPr algn="l">
-              <a:defRPr sz="1275" b="0">
+              <a:defRPr sz="1200" b="0">
                 <a:solidFill>
                   <a:srgbClr val="596273"/>
                 </a:solidFill>
@@ -1303,7 +1304,8 @@
               </a:defRPr>
             </a:pPr>
             <a:r>
-              <a:t>Cordant supplies proposed context; MTP gates the action; an operator signed pack can be verified without calling Inntris.</a:t>
+              <a:t>Cordant supplies the proposed context; Inntris MTP returns an allow or deny decision; the executor enforces it;
+an operator-signed evidence pack can be verified offline without calling Inntris.</a:t>
             </a:r>
           </a:p>
         </p:txBody>
@@ -1316,7 +1318,7 @@
         </p:nvCxnSpPr>
         <p:spPr>
           <a:xfrm xmlns:a="http://schemas.openxmlformats.org/drawingml/2006/main">
-            <a:off x="495300" y="1381125"/>
+            <a:off x="495300" y="1543050"/>
             <a:ext cx="11201400" cy="953"/>
           </a:xfrm>
           <a:prstGeom xmlns:a="http://schemas.openxmlformats.org/drawingml/2006/main" prst="straightConnector1">
@@ -1335,7 +1337,7 @@
           <p:cNvPr id="6" name="intent-flow-caption">
             <a:extLst xmlns:a="http://schemas.openxmlformats.org/drawingml/2006/main">
               <a:ext uri="{FF2B5EF4-FFF2-40B4-BE49-F238E27FC236}">
-                <a16:creationId xmlns:a16="http://schemas.microsoft.com/office/drawing/2014/main" id="{F27E9780-264A-44D3-94F2-F1CECD8F96D5}"/>
+                <a16:creationId xmlns:a16="http://schemas.microsoft.com/office/drawing/2014/main" id="{E7964F7B-A60F-44B9-A98F-338E4FBF54EF}"/>
               </a:ext>
             </a:extLst>
           </p:cNvPr>
@@ -1355,7 +1357,7 @@
         </p:spPr>
         <p:txBody>
           <a:bodyPr xmlns:a="http://schemas.openxmlformats.org/drawingml/2006/main" lIns="0" tIns="0" rIns="0" bIns="0" anchor="ctr">
-            <a:normAutofit fontScale="78892"/>
+            <a:normAutofit fontScale="66516"/>
           </a:bodyPr>
           <a:lstStyle xmlns:a="http://schemas.openxmlformats.org/drawingml/2006/main"/>
           <a:p xmlns:a="http://schemas.openxmlformats.org/drawingml/2006/main">
@@ -1370,7 +1372,8 @@
               </a:defRPr>
             </a:pPr>
             <a:r>
-              <a:t>SIGNED INTENT</a:t>
+              <a:t>SIGNED ACTION
+INTENT</a:t>
             </a:r>
           </a:p>
         </p:txBody>
@@ -1380,7 +1383,7 @@
           <p:cNvPr id="7" name="intent-flow-arrow">
             <a:extLst xmlns:a="http://schemas.openxmlformats.org/drawingml/2006/main">
               <a:ext uri="{FF2B5EF4-FFF2-40B4-BE49-F238E27FC236}">
-                <a16:creationId xmlns:a16="http://schemas.microsoft.com/office/drawing/2014/main" id="{30181B91-40D3-4615-BC32-D793BF640D76}"/>
+                <a16:creationId xmlns:a16="http://schemas.microsoft.com/office/drawing/2014/main" id="{23AC2BB5-E7A2-42F7-A8D1-0E94D5620CE3}"/>
               </a:ext>
             </a:extLst>
           </p:cNvPr>
@@ -1425,7 +1428,7 @@
           <p:cNvPr id="8" name="decision-flow-caption">
             <a:extLst xmlns:a="http://schemas.openxmlformats.org/drawingml/2006/main">
               <a:ext uri="{FF2B5EF4-FFF2-40B4-BE49-F238E27FC236}">
-                <a16:creationId xmlns:a16="http://schemas.microsoft.com/office/drawing/2014/main" id="{39D33B2C-9104-4E05-ADDF-918FC1E5616C}"/>
+                <a16:creationId xmlns:a16="http://schemas.microsoft.com/office/drawing/2014/main" id="{418718AC-1B8F-45F1-95C9-C49EC3D2CD83}"/>
               </a:ext>
             </a:extLst>
           </p:cNvPr>
@@ -1445,7 +1448,7 @@
         </p:spPr>
         <p:txBody>
           <a:bodyPr xmlns:a="http://schemas.openxmlformats.org/drawingml/2006/main" lIns="0" tIns="0" rIns="0" bIns="0" anchor="ctr">
-            <a:normAutofit fontScale="78892"/>
+            <a:normAutofit fontScale="70966"/>
           </a:bodyPr>
           <a:lstStyle xmlns:a="http://schemas.openxmlformats.org/drawingml/2006/main"/>
           <a:p xmlns:a="http://schemas.openxmlformats.org/drawingml/2006/main">
@@ -1460,7 +1463,8 @@
               </a:defRPr>
             </a:pPr>
             <a:r>
-              <a:t>TOKEN OR DENY</a:t>
+              <a:t>ALLOW TOKEN
+OR DENY</a:t>
             </a:r>
           </a:p>
         </p:txBody>
@@ -1470,7 +1474,7 @@
           <p:cNvPr id="9" name="decision-flow-arrow">
             <a:extLst xmlns:a="http://schemas.openxmlformats.org/drawingml/2006/main">
               <a:ext uri="{FF2B5EF4-FFF2-40B4-BE49-F238E27FC236}">
-                <a16:creationId xmlns:a16="http://schemas.microsoft.com/office/drawing/2014/main" id="{80A43E6E-FCC3-4774-B2CB-6373BE35D783}"/>
+                <a16:creationId xmlns:a16="http://schemas.microsoft.com/office/drawing/2014/main" id="{885F9BDF-6178-4F35-B16F-3C24106450BB}"/>
               </a:ext>
             </a:extLst>
           </p:cNvPr>
@@ -1515,7 +1519,7 @@
           <p:cNvPr id="10" name="cordant-panel">
             <a:extLst xmlns:a="http://schemas.openxmlformats.org/drawingml/2006/main">
               <a:ext uri="{FF2B5EF4-FFF2-40B4-BE49-F238E27FC236}">
-                <a16:creationId xmlns:a16="http://schemas.microsoft.com/office/drawing/2014/main" id="{57B0FB55-8105-4602-B434-65E1306D7A8B}"/>
+                <a16:creationId xmlns:a16="http://schemas.microsoft.com/office/drawing/2014/main" id="{0439DE9A-9C95-4AD0-B8C5-2A1B84B62FA4}"/>
               </a:ext>
             </a:extLst>
           </p:cNvPr>
@@ -1548,7 +1552,7 @@
           <p:cNvPr id="11" name="cordant-accent">
             <a:extLst xmlns:a="http://schemas.openxmlformats.org/drawingml/2006/main">
               <a:ext uri="{FF2B5EF4-FFF2-40B4-BE49-F238E27FC236}">
-                <a16:creationId xmlns:a16="http://schemas.microsoft.com/office/drawing/2014/main" id="{A0CA6AF3-CBB3-45DC-9CF6-46F8D2F97EE2}"/>
+                <a16:creationId xmlns:a16="http://schemas.microsoft.com/office/drawing/2014/main" id="{0DC2992C-DA79-4072-8806-AC6AB82393CB}"/>
               </a:ext>
             </a:extLst>
           </p:cNvPr>
@@ -1581,7 +1585,7 @@
           <p:cNvPr id="12" name="cordant-plane">
             <a:extLst xmlns:a="http://schemas.openxmlformats.org/drawingml/2006/main">
               <a:ext uri="{FF2B5EF4-FFF2-40B4-BE49-F238E27FC236}">
-                <a16:creationId xmlns:a16="http://schemas.microsoft.com/office/drawing/2014/main" id="{FB3DB3F0-08AF-4DBD-BF07-9900DA872143}"/>
+                <a16:creationId xmlns:a16="http://schemas.microsoft.com/office/drawing/2014/main" id="{D9A805EA-04B6-4B40-9926-306147C6FEE2}"/>
               </a:ext>
             </a:extLst>
           </p:cNvPr>
@@ -1626,7 +1630,7 @@
           <p:cNvPr id="13" name="cordant-title">
             <a:extLst xmlns:a="http://schemas.openxmlformats.org/drawingml/2006/main">
               <a:ext uri="{FF2B5EF4-FFF2-40B4-BE49-F238E27FC236}">
-                <a16:creationId xmlns:a16="http://schemas.microsoft.com/office/drawing/2014/main" id="{7FF31CC8-D547-4CE6-8762-A5178BB314E3}"/>
+                <a16:creationId xmlns:a16="http://schemas.microsoft.com/office/drawing/2014/main" id="{5C832027-CE04-44F8-846F-AB51F7A3BC27}"/>
               </a:ext>
             </a:extLst>
           </p:cNvPr>
@@ -1693,7 +1697,7 @@
           <p:cNvPr id="15" name="cordant-connect-dot">
             <a:extLst xmlns:a="http://schemas.openxmlformats.org/drawingml/2006/main">
               <a:ext uri="{FF2B5EF4-FFF2-40B4-BE49-F238E27FC236}">
-                <a16:creationId xmlns:a16="http://schemas.microsoft.com/office/drawing/2014/main" id="{2EE7CFA0-8520-4D68-9318-EC2BAA7DBD8D}"/>
+                <a16:creationId xmlns:a16="http://schemas.microsoft.com/office/drawing/2014/main" id="{5829435B-9AFF-4911-A4CE-916DC9826E6C}"/>
               </a:ext>
             </a:extLst>
           </p:cNvPr>
@@ -1726,7 +1730,7 @@
           <p:cNvPr id="16" name="cordant-connect-text">
             <a:extLst xmlns:a="http://schemas.openxmlformats.org/drawingml/2006/main">
               <a:ext uri="{FF2B5EF4-FFF2-40B4-BE49-F238E27FC236}">
-                <a16:creationId xmlns:a16="http://schemas.microsoft.com/office/drawing/2014/main" id="{94B61158-2BA0-48AC-AF1E-6C0A507C4FE7}"/>
+                <a16:creationId xmlns:a16="http://schemas.microsoft.com/office/drawing/2014/main" id="{8AE5867B-6E8A-4303-AFD7-E35DFC47296F}"/>
               </a:ext>
             </a:extLst>
           </p:cNvPr>
@@ -1771,7 +1775,7 @@
           <p:cNvPr id="17" name="cordant-normalise-dot">
             <a:extLst xmlns:a="http://schemas.openxmlformats.org/drawingml/2006/main">
               <a:ext uri="{FF2B5EF4-FFF2-40B4-BE49-F238E27FC236}">
-                <a16:creationId xmlns:a16="http://schemas.microsoft.com/office/drawing/2014/main" id="{65589C60-2752-4070-AB77-DB9CAFCCAB73}"/>
+                <a16:creationId xmlns:a16="http://schemas.microsoft.com/office/drawing/2014/main" id="{9DCCD2A9-F862-4F74-947B-84B25F32E880}"/>
               </a:ext>
             </a:extLst>
           </p:cNvPr>
@@ -1804,7 +1808,7 @@
           <p:cNvPr id="18" name="cordant-normalise-text">
             <a:extLst xmlns:a="http://schemas.openxmlformats.org/drawingml/2006/main">
               <a:ext uri="{FF2B5EF4-FFF2-40B4-BE49-F238E27FC236}">
-                <a16:creationId xmlns:a16="http://schemas.microsoft.com/office/drawing/2014/main" id="{A0B926D6-8372-4055-ADF1-DA83420E7B96}"/>
+                <a16:creationId xmlns:a16="http://schemas.microsoft.com/office/drawing/2014/main" id="{205E1AC7-1532-47EA-BFF7-2AE90F2FC30F}"/>
               </a:ext>
             </a:extLst>
           </p:cNvPr>
@@ -1849,7 +1853,7 @@
           <p:cNvPr id="19" name="cordant-propose-dot">
             <a:extLst xmlns:a="http://schemas.openxmlformats.org/drawingml/2006/main">
               <a:ext uri="{FF2B5EF4-FFF2-40B4-BE49-F238E27FC236}">
-                <a16:creationId xmlns:a16="http://schemas.microsoft.com/office/drawing/2014/main" id="{598EF6C2-FC2A-4150-A84E-D7BA3785FE12}"/>
+                <a16:creationId xmlns:a16="http://schemas.microsoft.com/office/drawing/2014/main" id="{0D6CAA68-DE2D-4BF5-8544-743B4605CC1E}"/>
               </a:ext>
             </a:extLst>
           </p:cNvPr>
@@ -1882,7 +1886,7 @@
           <p:cNvPr id="20" name="cordant-propose-text">
             <a:extLst xmlns:a="http://schemas.openxmlformats.org/drawingml/2006/main">
               <a:ext uri="{FF2B5EF4-FFF2-40B4-BE49-F238E27FC236}">
-                <a16:creationId xmlns:a16="http://schemas.microsoft.com/office/drawing/2014/main" id="{7B9872A4-EC15-45D4-AADF-D8AE05235427}"/>
+                <a16:creationId xmlns:a16="http://schemas.microsoft.com/office/drawing/2014/main" id="{7F9A7E0A-9BB1-43F1-9E4F-62620A6FF1EF}"/>
               </a:ext>
             </a:extLst>
           </p:cNvPr>
@@ -1927,7 +1931,7 @@
           <p:cNvPr id="21" name="cordant-boundary">
             <a:extLst xmlns:a="http://schemas.openxmlformats.org/drawingml/2006/main">
               <a:ext uri="{FF2B5EF4-FFF2-40B4-BE49-F238E27FC236}">
-                <a16:creationId xmlns:a16="http://schemas.microsoft.com/office/drawing/2014/main" id="{BD455DBC-BEBF-4179-9DC2-C7EF12B1011C}"/>
+                <a16:creationId xmlns:a16="http://schemas.microsoft.com/office/drawing/2014/main" id="{17F05388-39AF-4DE7-B1B2-1284625E6704}"/>
               </a:ext>
             </a:extLst>
           </p:cNvPr>
@@ -1972,7 +1976,7 @@
           <p:cNvPr id="22" name="mtp-panel">
             <a:extLst xmlns:a="http://schemas.openxmlformats.org/drawingml/2006/main">
               <a:ext uri="{FF2B5EF4-FFF2-40B4-BE49-F238E27FC236}">
-                <a16:creationId xmlns:a16="http://schemas.microsoft.com/office/drawing/2014/main" id="{7CC7FE07-2A37-4DC8-9DE1-161BC29BED5A}"/>
+                <a16:creationId xmlns:a16="http://schemas.microsoft.com/office/drawing/2014/main" id="{105203A7-4BCE-40DF-854C-D9EBAE8933EA}"/>
               </a:ext>
             </a:extLst>
           </p:cNvPr>
@@ -2005,7 +2009,7 @@
           <p:cNvPr id="23" name="mtp-accent">
             <a:extLst xmlns:a="http://schemas.openxmlformats.org/drawingml/2006/main">
               <a:ext uri="{FF2B5EF4-FFF2-40B4-BE49-F238E27FC236}">
-                <a16:creationId xmlns:a16="http://schemas.microsoft.com/office/drawing/2014/main" id="{E98DCC32-4492-40CF-935C-5D8B73DE69A8}"/>
+                <a16:creationId xmlns:a16="http://schemas.microsoft.com/office/drawing/2014/main" id="{FB9D8840-970F-44C7-9AB0-52A8C23E37B4}"/>
               </a:ext>
             </a:extLst>
           </p:cNvPr>
@@ -2038,7 +2042,7 @@
           <p:cNvPr id="24" name="mtp-plane">
             <a:extLst xmlns:a="http://schemas.openxmlformats.org/drawingml/2006/main">
               <a:ext uri="{FF2B5EF4-FFF2-40B4-BE49-F238E27FC236}">
-                <a16:creationId xmlns:a16="http://schemas.microsoft.com/office/drawing/2014/main" id="{B82A7F65-5ECB-4B64-B42B-4C43096251BA}"/>
+                <a16:creationId xmlns:a16="http://schemas.microsoft.com/office/drawing/2014/main" id="{FFFF4F79-EA51-4AB3-A8D7-1B527423A956}"/>
               </a:ext>
             </a:extLst>
           </p:cNvPr>
@@ -2083,7 +2087,7 @@
           <p:cNvPr id="25" name="mtp-title">
             <a:extLst xmlns:a="http://schemas.openxmlformats.org/drawingml/2006/main">
               <a:ext uri="{FF2B5EF4-FFF2-40B4-BE49-F238E27FC236}">
-                <a16:creationId xmlns:a16="http://schemas.microsoft.com/office/drawing/2014/main" id="{72853CC2-6BCF-45D2-AA2D-1847AE8BE530}"/>
+                <a16:creationId xmlns:a16="http://schemas.microsoft.com/office/drawing/2014/main" id="{17B4F8FE-A969-481B-873F-8742CEF86F89}"/>
               </a:ext>
             </a:extLst>
           </p:cNvPr>
@@ -2150,7 +2154,7 @@
           <p:cNvPr id="27" name="mtp-route-dot">
             <a:extLst xmlns:a="http://schemas.openxmlformats.org/drawingml/2006/main">
               <a:ext uri="{FF2B5EF4-FFF2-40B4-BE49-F238E27FC236}">
-                <a16:creationId xmlns:a16="http://schemas.microsoft.com/office/drawing/2014/main" id="{84851D9D-3039-4F90-8283-9BD890DE8B9B}"/>
+                <a16:creationId xmlns:a16="http://schemas.microsoft.com/office/drawing/2014/main" id="{D8088DBC-A855-4BF2-BAD8-8B8C8B1E1888}"/>
               </a:ext>
             </a:extLst>
           </p:cNvPr>
@@ -2183,7 +2187,7 @@
           <p:cNvPr id="28" name="mtp-route-text">
             <a:extLst xmlns:a="http://schemas.openxmlformats.org/drawingml/2006/main">
               <a:ext uri="{FF2B5EF4-FFF2-40B4-BE49-F238E27FC236}">
-                <a16:creationId xmlns:a16="http://schemas.microsoft.com/office/drawing/2014/main" id="{A6A897C7-9615-476D-AD5E-4A7E131FBE03}"/>
+                <a16:creationId xmlns:a16="http://schemas.microsoft.com/office/drawing/2014/main" id="{A07FEA7C-DF18-4C5F-9A48-C93E6F16AA5A}"/>
               </a:ext>
             </a:extLst>
           </p:cNvPr>
@@ -2228,7 +2232,7 @@
           <p:cNvPr id="29" name="mtp-checks-dot">
             <a:extLst xmlns:a="http://schemas.openxmlformats.org/drawingml/2006/main">
               <a:ext uri="{FF2B5EF4-FFF2-40B4-BE49-F238E27FC236}">
-                <a16:creationId xmlns:a16="http://schemas.microsoft.com/office/drawing/2014/main" id="{11F4F39F-AFED-4D32-80A0-864F76A0E159}"/>
+                <a16:creationId xmlns:a16="http://schemas.microsoft.com/office/drawing/2014/main" id="{349D847D-E1AB-43F9-BCEC-22E0AFFD76A6}"/>
               </a:ext>
             </a:extLst>
           </p:cNvPr>
@@ -2261,7 +2265,7 @@
           <p:cNvPr id="30" name="mtp-checks-text">
             <a:extLst xmlns:a="http://schemas.openxmlformats.org/drawingml/2006/main">
               <a:ext uri="{FF2B5EF4-FFF2-40B4-BE49-F238E27FC236}">
-                <a16:creationId xmlns:a16="http://schemas.microsoft.com/office/drawing/2014/main" id="{79249B91-5567-4088-B809-AC8B16E7B011}"/>
+                <a16:creationId xmlns:a16="http://schemas.microsoft.com/office/drawing/2014/main" id="{AE2EBB54-CC26-4AE7-9772-160C85E6BEF7}"/>
               </a:ext>
             </a:extLst>
           </p:cNvPr>
@@ -2306,7 +2310,7 @@
           <p:cNvPr id="31" name="mtp-decision-dot">
             <a:extLst xmlns:a="http://schemas.openxmlformats.org/drawingml/2006/main">
               <a:ext uri="{FF2B5EF4-FFF2-40B4-BE49-F238E27FC236}">
-                <a16:creationId xmlns:a16="http://schemas.microsoft.com/office/drawing/2014/main" id="{320470B3-608A-459D-9DF2-928E9B6E9947}"/>
+                <a16:creationId xmlns:a16="http://schemas.microsoft.com/office/drawing/2014/main" id="{212E3F1E-B11E-441C-A15A-011C671089C0}"/>
               </a:ext>
             </a:extLst>
           </p:cNvPr>
@@ -2339,7 +2343,7 @@
           <p:cNvPr id="32" name="mtp-decision-text">
             <a:extLst xmlns:a="http://schemas.openxmlformats.org/drawingml/2006/main">
               <a:ext uri="{FF2B5EF4-FFF2-40B4-BE49-F238E27FC236}">
-                <a16:creationId xmlns:a16="http://schemas.microsoft.com/office/drawing/2014/main" id="{42E52E79-138A-44F7-BF9F-CDE31967FE4F}"/>
+                <a16:creationId xmlns:a16="http://schemas.microsoft.com/office/drawing/2014/main" id="{BC459645-3B05-44CA-B58D-5C1D8EEFFD46}"/>
               </a:ext>
             </a:extLst>
           </p:cNvPr>
@@ -2384,7 +2388,7 @@
           <p:cNvPr id="33" name="mtp-invalid">
             <a:extLst xmlns:a="http://schemas.openxmlformats.org/drawingml/2006/main">
               <a:ext uri="{FF2B5EF4-FFF2-40B4-BE49-F238E27FC236}">
-                <a16:creationId xmlns:a16="http://schemas.microsoft.com/office/drawing/2014/main" id="{4FA2AA06-5C21-4124-B550-38ABF9864811}"/>
+                <a16:creationId xmlns:a16="http://schemas.microsoft.com/office/drawing/2014/main" id="{C2849EA3-FAE8-48FF-A62C-D185283C70E9}"/>
               </a:ext>
             </a:extLst>
           </p:cNvPr>
@@ -2429,7 +2433,7 @@
           <p:cNvPr id="34" name="execution-panel">
             <a:extLst xmlns:a="http://schemas.openxmlformats.org/drawingml/2006/main">
               <a:ext uri="{FF2B5EF4-FFF2-40B4-BE49-F238E27FC236}">
-                <a16:creationId xmlns:a16="http://schemas.microsoft.com/office/drawing/2014/main" id="{2F36C3CD-3123-41D5-977D-1EF7DB3C522C}"/>
+                <a16:creationId xmlns:a16="http://schemas.microsoft.com/office/drawing/2014/main" id="{4069CA67-DFBA-445A-8DE0-967F0AF7D3D5}"/>
               </a:ext>
             </a:extLst>
           </p:cNvPr>
@@ -2462,7 +2466,7 @@
           <p:cNvPr id="35" name="execution-plane">
             <a:extLst xmlns:a="http://schemas.openxmlformats.org/drawingml/2006/main">
               <a:ext uri="{FF2B5EF4-FFF2-40B4-BE49-F238E27FC236}">
-                <a16:creationId xmlns:a16="http://schemas.microsoft.com/office/drawing/2014/main" id="{1FCBB7A4-83A8-4A69-9274-68BBA38581DA}"/>
+                <a16:creationId xmlns:a16="http://schemas.microsoft.com/office/drawing/2014/main" id="{5D590DE4-E06D-401E-83F7-2CE87C547066}"/>
               </a:ext>
             </a:extLst>
           </p:cNvPr>
@@ -2507,7 +2511,7 @@
           <p:cNvPr id="36" name="execution-title">
             <a:extLst xmlns:a="http://schemas.openxmlformats.org/drawingml/2006/main">
               <a:ext uri="{FF2B5EF4-FFF2-40B4-BE49-F238E27FC236}">
-                <a16:creationId xmlns:a16="http://schemas.microsoft.com/office/drawing/2014/main" id="{1E36E9F2-F58C-47DE-8268-50674E6E92F6}"/>
+                <a16:creationId xmlns:a16="http://schemas.microsoft.com/office/drawing/2014/main" id="{95E6FDC1-0EBA-48B6-A6A3-025BB928B3FA}"/>
               </a:ext>
             </a:extLst>
           </p:cNvPr>
@@ -2574,7 +2578,7 @@
           <p:cNvPr id="38" name="execution-route">
             <a:extLst xmlns:a="http://schemas.openxmlformats.org/drawingml/2006/main">
               <a:ext uri="{FF2B5EF4-FFF2-40B4-BE49-F238E27FC236}">
-                <a16:creationId xmlns:a16="http://schemas.microsoft.com/office/drawing/2014/main" id="{2449AE93-EE87-4E07-BC38-96D1842AF9E9}"/>
+                <a16:creationId xmlns:a16="http://schemas.microsoft.com/office/drawing/2014/main" id="{A9D84C84-BEB6-47FB-A238-D5263461BD4F}"/>
               </a:ext>
             </a:extLst>
           </p:cNvPr>
@@ -2619,7 +2623,7 @@
           <p:cNvPr id="39" name="execution-inputs">
             <a:extLst xmlns:a="http://schemas.openxmlformats.org/drawingml/2006/main">
               <a:ext uri="{FF2B5EF4-FFF2-40B4-BE49-F238E27FC236}">
-                <a16:creationId xmlns:a16="http://schemas.microsoft.com/office/drawing/2014/main" id="{BF8E1925-19C2-44F9-8289-9B66D5EF2B8A}"/>
+                <a16:creationId xmlns:a16="http://schemas.microsoft.com/office/drawing/2014/main" id="{383300A1-BD1C-41E1-BF2C-ED0E0D20C761}"/>
               </a:ext>
             </a:extLst>
           </p:cNvPr>
@@ -2654,7 +2658,7 @@
               </a:defRPr>
             </a:pPr>
             <a:r>
-              <a:t>All action inputs + consume: true</a:t>
+              <a:t>Forward exact action inputs + consume: true</a:t>
             </a:r>
           </a:p>
         </p:txBody>
@@ -2664,7 +2668,7 @@
           <p:cNvPr id="40" name="execution-proceed">
             <a:extLst xmlns:a="http://schemas.openxmlformats.org/drawingml/2006/main">
               <a:ext uri="{FF2B5EF4-FFF2-40B4-BE49-F238E27FC236}">
-                <a16:creationId xmlns:a16="http://schemas.microsoft.com/office/drawing/2014/main" id="{311D4E85-016C-41BD-AB53-A37C4CEC25CA}"/>
+                <a16:creationId xmlns:a16="http://schemas.microsoft.com/office/drawing/2014/main" id="{98912F8E-BFE6-47A2-AEBC-C8E34EDFEE8C}"/>
               </a:ext>
             </a:extLst>
           </p:cNvPr>
@@ -2709,7 +2713,7 @@
           <p:cNvPr id="41" name="execution-stop">
             <a:extLst xmlns:a="http://schemas.openxmlformats.org/drawingml/2006/main">
               <a:ext uri="{FF2B5EF4-FFF2-40B4-BE49-F238E27FC236}">
-                <a16:creationId xmlns:a16="http://schemas.microsoft.com/office/drawing/2014/main" id="{24A27C82-543C-4B6F-8AFA-D7FD81D68A5E}"/>
+                <a16:creationId xmlns:a16="http://schemas.microsoft.com/office/drawing/2014/main" id="{E7C42471-73E2-4FC0-BB0E-AEFB015850A0}"/>
               </a:ext>
             </a:extLst>
           </p:cNvPr>
@@ -2754,7 +2758,7 @@
           <p:cNvPr id="42" name="callback-label">
             <a:extLst xmlns:a="http://schemas.openxmlformats.org/drawingml/2006/main">
               <a:ext uri="{FF2B5EF4-FFF2-40B4-BE49-F238E27FC236}">
-                <a16:creationId xmlns:a16="http://schemas.microsoft.com/office/drawing/2014/main" id="{F0B97579-6018-4F27-BF0D-976309B991AD}"/>
+                <a16:creationId xmlns:a16="http://schemas.microsoft.com/office/drawing/2014/main" id="{9BF738CF-1E0C-455F-81E4-5365B34F56B2}"/>
               </a:ext>
             </a:extLst>
           </p:cNvPr>
@@ -2787,7 +2791,7 @@
           <p:cNvPr id="43" name="callback-title">
             <a:extLst xmlns:a="http://schemas.openxmlformats.org/drawingml/2006/main">
               <a:ext uri="{FF2B5EF4-FFF2-40B4-BE49-F238E27FC236}">
-                <a16:creationId xmlns:a16="http://schemas.microsoft.com/office/drawing/2014/main" id="{63BFFB48-48B5-413C-8A5C-8C4A88F32A7B}"/>
+                <a16:creationId xmlns:a16="http://schemas.microsoft.com/office/drawing/2014/main" id="{CC5269DF-2FF6-4419-9761-85525E4AACA1}"/>
               </a:ext>
             </a:extLst>
           </p:cNvPr>
@@ -2832,7 +2836,7 @@
           <p:cNvPr id="44" name="callback-direction">
             <a:extLst xmlns:a="http://schemas.openxmlformats.org/drawingml/2006/main">
               <a:ext uri="{FF2B5EF4-FFF2-40B4-BE49-F238E27FC236}">
-                <a16:creationId xmlns:a16="http://schemas.microsoft.com/office/drawing/2014/main" id="{C5E4B798-2562-4E2E-AE88-592A1CD58298}"/>
+                <a16:creationId xmlns:a16="http://schemas.microsoft.com/office/drawing/2014/main" id="{0D0C5792-1E55-4F3E-96D1-3580F8C30017}"/>
               </a:ext>
             </a:extLst>
           </p:cNvPr>
@@ -2877,7 +2881,7 @@
           <p:cNvPr id="45" name="callback-body">
             <a:extLst xmlns:a="http://schemas.openxmlformats.org/drawingml/2006/main">
               <a:ext uri="{FF2B5EF4-FFF2-40B4-BE49-F238E27FC236}">
-                <a16:creationId xmlns:a16="http://schemas.microsoft.com/office/drawing/2014/main" id="{C1C238FF-CF35-41F5-ABB2-52F94D9B4EB5}"/>
+                <a16:creationId xmlns:a16="http://schemas.microsoft.com/office/drawing/2014/main" id="{54D8CEAE-B805-4E1B-9981-21873C16BBC5}"/>
               </a:ext>
             </a:extLst>
           </p:cNvPr>
@@ -2910,7 +2914,7 @@
           <p:cNvPr id="46" name="callback-copy">
             <a:extLst xmlns:a="http://schemas.openxmlformats.org/drawingml/2006/main">
               <a:ext uri="{FF2B5EF4-FFF2-40B4-BE49-F238E27FC236}">
-                <a16:creationId xmlns:a16="http://schemas.microsoft.com/office/drawing/2014/main" id="{BB216063-CA1F-424B-B77A-EB6DC88A3898}"/>
+                <a16:creationId xmlns:a16="http://schemas.microsoft.com/office/drawing/2014/main" id="{229B5378-9A8B-4164-AC36-172181229EC7}"/>
               </a:ext>
             </a:extLst>
           </p:cNvPr>
@@ -2945,7 +2949,7 @@
               </a:defRPr>
             </a:pPr>
             <a:r>
-              <a:t>MTP returns event, verdict, audit ID and reason to Cordant. Receipt and proof remain separate fetches.</a:t>
+              <a:t>MTP returns the event, verdict, audit ID and reason to Cordant. Receipts and proofs remain separate endpoints.</a:t>
             </a:r>
           </a:p>
         </p:txBody>
@@ -2955,7 +2959,7 @@
           <p:cNvPr id="47" name="pack-flow-caption">
             <a:extLst xmlns:a="http://schemas.openxmlformats.org/drawingml/2006/main">
               <a:ext uri="{FF2B5EF4-FFF2-40B4-BE49-F238E27FC236}">
-                <a16:creationId xmlns:a16="http://schemas.microsoft.com/office/drawing/2014/main" id="{3378091C-080D-481A-B529-C58FE46C0161}"/>
+                <a16:creationId xmlns:a16="http://schemas.microsoft.com/office/drawing/2014/main" id="{8C1816B5-82D1-4030-89C4-3A30F48A06A2}"/>
               </a:ext>
             </a:extLst>
           </p:cNvPr>
@@ -3000,7 +3004,7 @@
           <p:cNvPr id="48" name="pack-flow-arrow">
             <a:extLst xmlns:a="http://schemas.openxmlformats.org/drawingml/2006/main">
               <a:ext uri="{FF2B5EF4-FFF2-40B4-BE49-F238E27FC236}">
-                <a16:creationId xmlns:a16="http://schemas.microsoft.com/office/drawing/2014/main" id="{02D2CAFD-37D5-4AEE-B58C-7A17DF509A72}"/>
+                <a16:creationId xmlns:a16="http://schemas.microsoft.com/office/drawing/2014/main" id="{E47D147A-66B6-4DD9-BB31-08D16BE70FEA}"/>
               </a:ext>
             </a:extLst>
           </p:cNvPr>
@@ -3045,7 +3049,7 @@
           <p:cNvPr id="49" name="verify-flow-caption">
             <a:extLst xmlns:a="http://schemas.openxmlformats.org/drawingml/2006/main">
               <a:ext uri="{FF2B5EF4-FFF2-40B4-BE49-F238E27FC236}">
-                <a16:creationId xmlns:a16="http://schemas.microsoft.com/office/drawing/2014/main" id="{A1DDC28E-2B5D-4D7E-8883-7FB8081468E4}"/>
+                <a16:creationId xmlns:a16="http://schemas.microsoft.com/office/drawing/2014/main" id="{1475E863-A2FB-4093-8867-4378AA109E01}"/>
               </a:ext>
             </a:extLst>
           </p:cNvPr>
@@ -3090,7 +3094,7 @@
           <p:cNvPr id="50" name="verify-flow-arrow">
             <a:extLst xmlns:a="http://schemas.openxmlformats.org/drawingml/2006/main">
               <a:ext uri="{FF2B5EF4-FFF2-40B4-BE49-F238E27FC236}">
-                <a16:creationId xmlns:a16="http://schemas.microsoft.com/office/drawing/2014/main" id="{034B7391-0107-4A9C-AB17-6A473C78FD71}"/>
+                <a16:creationId xmlns:a16="http://schemas.microsoft.com/office/drawing/2014/main" id="{32E9E58F-7FEE-4920-BB2A-D0F5E4B49224}"/>
               </a:ext>
             </a:extLst>
           </p:cNvPr>
@@ -3135,7 +3139,7 @@
           <p:cNvPr id="51" name="evidence-panel">
             <a:extLst xmlns:a="http://schemas.openxmlformats.org/drawingml/2006/main">
               <a:ext uri="{FF2B5EF4-FFF2-40B4-BE49-F238E27FC236}">
-                <a16:creationId xmlns:a16="http://schemas.microsoft.com/office/drawing/2014/main" id="{25C00943-FF7E-4E8F-9A9A-495D3EAE5DC3}"/>
+                <a16:creationId xmlns:a16="http://schemas.microsoft.com/office/drawing/2014/main" id="{B0C226FA-20EC-4C4E-8AC7-821A27E5AE89}"/>
               </a:ext>
             </a:extLst>
           </p:cNvPr>
@@ -3168,7 +3172,7 @@
           <p:cNvPr id="52" name="evidence-plane">
             <a:extLst xmlns:a="http://schemas.openxmlformats.org/drawingml/2006/main">
               <a:ext uri="{FF2B5EF4-FFF2-40B4-BE49-F238E27FC236}">
-                <a16:creationId xmlns:a16="http://schemas.microsoft.com/office/drawing/2014/main" id="{A2C15749-28FF-456C-801D-DFB170F8911B}"/>
+                <a16:creationId xmlns:a16="http://schemas.microsoft.com/office/drawing/2014/main" id="{E6761E7B-960E-4DC2-951A-6E6F1627BFC2}"/>
               </a:ext>
             </a:extLst>
           </p:cNvPr>
@@ -3213,7 +3217,7 @@
           <p:cNvPr id="53" name="evidence-title">
             <a:extLst xmlns:a="http://schemas.openxmlformats.org/drawingml/2006/main">
               <a:ext uri="{FF2B5EF4-FFF2-40B4-BE49-F238E27FC236}">
-                <a16:creationId xmlns:a16="http://schemas.microsoft.com/office/drawing/2014/main" id="{21F0885C-E535-49B1-BE5D-67C7205ABDF2}"/>
+                <a16:creationId xmlns:a16="http://schemas.microsoft.com/office/drawing/2014/main" id="{254F2677-00CE-42D0-81F1-1ABC8679640E}"/>
               </a:ext>
             </a:extLst>
           </p:cNvPr>
@@ -3258,7 +3262,7 @@
           <p:cNvPr id="54" name="evidence-receipt-dot">
             <a:extLst xmlns:a="http://schemas.openxmlformats.org/drawingml/2006/main">
               <a:ext uri="{FF2B5EF4-FFF2-40B4-BE49-F238E27FC236}">
-                <a16:creationId xmlns:a16="http://schemas.microsoft.com/office/drawing/2014/main" id="{2E809A21-6BCC-45D7-A4F3-08D84BCFEAAF}"/>
+                <a16:creationId xmlns:a16="http://schemas.microsoft.com/office/drawing/2014/main" id="{20D98BA2-D19A-4E09-B423-4246577BA7E9}"/>
               </a:ext>
             </a:extLst>
           </p:cNvPr>
@@ -3291,7 +3295,7 @@
           <p:cNvPr id="55" name="evidence-receipt-text">
             <a:extLst xmlns:a="http://schemas.openxmlformats.org/drawingml/2006/main">
               <a:ext uri="{FF2B5EF4-FFF2-40B4-BE49-F238E27FC236}">
-                <a16:creationId xmlns:a16="http://schemas.microsoft.com/office/drawing/2014/main" id="{057F8A79-B041-4769-B3D2-AD63134BAF54}"/>
+                <a16:creationId xmlns:a16="http://schemas.microsoft.com/office/drawing/2014/main" id="{FDEACAA8-3F25-4523-981E-9F2AB9359D39}"/>
               </a:ext>
             </a:extLst>
           </p:cNvPr>
@@ -3336,7 +3340,7 @@
           <p:cNvPr id="56" name="evidence-anchor-dot">
             <a:extLst xmlns:a="http://schemas.openxmlformats.org/drawingml/2006/main">
               <a:ext uri="{FF2B5EF4-FFF2-40B4-BE49-F238E27FC236}">
-                <a16:creationId xmlns:a16="http://schemas.microsoft.com/office/drawing/2014/main" id="{0D450ACD-9680-4670-B9BB-DD87148E9DA3}"/>
+                <a16:creationId xmlns:a16="http://schemas.microsoft.com/office/drawing/2014/main" id="{04FC93CE-E8E9-4D4F-BA4D-4C084903344C}"/>
               </a:ext>
             </a:extLst>
           </p:cNvPr>
@@ -3369,7 +3373,7 @@
           <p:cNvPr id="57" name="evidence-anchor-text">
             <a:extLst xmlns:a="http://schemas.openxmlformats.org/drawingml/2006/main">
               <a:ext uri="{FF2B5EF4-FFF2-40B4-BE49-F238E27FC236}">
-                <a16:creationId xmlns:a16="http://schemas.microsoft.com/office/drawing/2014/main" id="{2690A243-A1ED-4366-A778-B47F83543161}"/>
+                <a16:creationId xmlns:a16="http://schemas.microsoft.com/office/drawing/2014/main" id="{3BD1ED46-2B41-4118-B6F4-3C52EE0BF580}"/>
               </a:ext>
             </a:extLst>
           </p:cNvPr>
@@ -3389,7 +3393,7 @@
         </p:spPr>
         <p:txBody>
           <a:bodyPr xmlns:a="http://schemas.openxmlformats.org/drawingml/2006/main" lIns="0" tIns="0" rIns="0" bIns="0" anchor="ctr">
-            <a:normAutofit fontScale="100000"/>
+            <a:normAutofit fontScale="75000"/>
           </a:bodyPr>
           <a:lstStyle xmlns:a="http://schemas.openxmlformats.org/drawingml/2006/main"/>
           <a:p xmlns:a="http://schemas.openxmlformats.org/drawingml/2006/main">
@@ -3404,7 +3408,8 @@
               </a:defRPr>
             </a:pPr>
             <a:r>
-              <a:t>Eligible logs → Merkle root → Base 8453</a:t>
+              <a:t>Eligible logs → Merkle root
+Base mainnet · chain ID 8453</a:t>
             </a:r>
           </a:p>
         </p:txBody>
@@ -3414,7 +3419,7 @@
           <p:cNvPr id="58" name="evidence-proof">
             <a:extLst xmlns:a="http://schemas.openxmlformats.org/drawingml/2006/main">
               <a:ext uri="{FF2B5EF4-FFF2-40B4-BE49-F238E27FC236}">
-                <a16:creationId xmlns:a16="http://schemas.microsoft.com/office/drawing/2014/main" id="{9704A062-672B-4C2F-A650-0D85D36E38EF}"/>
+                <a16:creationId xmlns:a16="http://schemas.microsoft.com/office/drawing/2014/main" id="{4CFC508D-C3B6-4A12-A103-E84E8643561C}"/>
               </a:ext>
             </a:extLst>
           </p:cNvPr>
@@ -3459,7 +3464,7 @@
           <p:cNvPr id="59" name="pack-panel">
             <a:extLst xmlns:a="http://schemas.openxmlformats.org/drawingml/2006/main">
               <a:ext uri="{FF2B5EF4-FFF2-40B4-BE49-F238E27FC236}">
-                <a16:creationId xmlns:a16="http://schemas.microsoft.com/office/drawing/2014/main" id="{E3B5B3B7-3E37-40B0-8D0C-5D89120369DE}"/>
+                <a16:creationId xmlns:a16="http://schemas.microsoft.com/office/drawing/2014/main" id="{79D4C213-0FA0-4DDF-A595-F53569602089}"/>
               </a:ext>
             </a:extLst>
           </p:cNvPr>
@@ -3492,7 +3497,7 @@
           <p:cNvPr id="60" name="pack-accent">
             <a:extLst xmlns:a="http://schemas.openxmlformats.org/drawingml/2006/main">
               <a:ext uri="{FF2B5EF4-FFF2-40B4-BE49-F238E27FC236}">
-                <a16:creationId xmlns:a16="http://schemas.microsoft.com/office/drawing/2014/main" id="{D6021316-ED65-4BBD-9683-E9667E803A97}"/>
+                <a16:creationId xmlns:a16="http://schemas.microsoft.com/office/drawing/2014/main" id="{B6BFA077-C630-40CE-ADA3-6491444A75D6}"/>
               </a:ext>
             </a:extLst>
           </p:cNvPr>
@@ -3525,7 +3530,7 @@
           <p:cNvPr id="61" name="pack-plane">
             <a:extLst xmlns:a="http://schemas.openxmlformats.org/drawingml/2006/main">
               <a:ext uri="{FF2B5EF4-FFF2-40B4-BE49-F238E27FC236}">
-                <a16:creationId xmlns:a16="http://schemas.microsoft.com/office/drawing/2014/main" id="{518D90D2-04F5-4E75-B5CD-7962E2202CFC}"/>
+                <a16:creationId xmlns:a16="http://schemas.microsoft.com/office/drawing/2014/main" id="{0202692A-0378-4505-9111-B6A997540F20}"/>
               </a:ext>
             </a:extLst>
           </p:cNvPr>
@@ -3570,7 +3575,7 @@
           <p:cNvPr id="62" name="pack-title">
             <a:extLst xmlns:a="http://schemas.openxmlformats.org/drawingml/2006/main">
               <a:ext uri="{FF2B5EF4-FFF2-40B4-BE49-F238E27FC236}">
-                <a16:creationId xmlns:a16="http://schemas.microsoft.com/office/drawing/2014/main" id="{B11837E5-A0DA-45D5-86AB-79B2D7C74027}"/>
+                <a16:creationId xmlns:a16="http://schemas.microsoft.com/office/drawing/2014/main" id="{1B6F788C-4317-4897-AE37-2A3E75396DE2}"/>
               </a:ext>
             </a:extLst>
           </p:cNvPr>
@@ -3615,7 +3620,7 @@
           <p:cNvPr id="63" name="pack-custody-dot">
             <a:extLst xmlns:a="http://schemas.openxmlformats.org/drawingml/2006/main">
               <a:ext uri="{FF2B5EF4-FFF2-40B4-BE49-F238E27FC236}">
-                <a16:creationId xmlns:a16="http://schemas.microsoft.com/office/drawing/2014/main" id="{97111617-2BC8-4D7C-94AF-6193DDA05403}"/>
+                <a16:creationId xmlns:a16="http://schemas.microsoft.com/office/drawing/2014/main" id="{5DEF63BC-AA9D-477D-AC78-ECB3D13367BF}"/>
               </a:ext>
             </a:extLst>
           </p:cNvPr>
@@ -3648,7 +3653,7 @@
           <p:cNvPr id="64" name="pack-custody-text">
             <a:extLst xmlns:a="http://schemas.openxmlformats.org/drawingml/2006/main">
               <a:ext uri="{FF2B5EF4-FFF2-40B4-BE49-F238E27FC236}">
-                <a16:creationId xmlns:a16="http://schemas.microsoft.com/office/drawing/2014/main" id="{1795598D-CEBC-489B-B796-0076324DA055}"/>
+                <a16:creationId xmlns:a16="http://schemas.microsoft.com/office/drawing/2014/main" id="{628E187F-75C7-4BEA-814C-F09EAA3F0D31}"/>
               </a:ext>
             </a:extLst>
           </p:cNvPr>
@@ -3693,7 +3698,7 @@
           <p:cNvPr id="65" name="pack-content-dot">
             <a:extLst xmlns:a="http://schemas.openxmlformats.org/drawingml/2006/main">
               <a:ext uri="{FF2B5EF4-FFF2-40B4-BE49-F238E27FC236}">
-                <a16:creationId xmlns:a16="http://schemas.microsoft.com/office/drawing/2014/main" id="{B36C2018-1D84-4BA1-9C31-F0D2EB777FC1}"/>
+                <a16:creationId xmlns:a16="http://schemas.microsoft.com/office/drawing/2014/main" id="{86167646-B9DA-45DE-AB90-F14D309CB1A7}"/>
               </a:ext>
             </a:extLst>
           </p:cNvPr>
@@ -3726,7 +3731,7 @@
           <p:cNvPr id="66" name="pack-content-text">
             <a:extLst xmlns:a="http://schemas.openxmlformats.org/drawingml/2006/main">
               <a:ext uri="{FF2B5EF4-FFF2-40B4-BE49-F238E27FC236}">
-                <a16:creationId xmlns:a16="http://schemas.microsoft.com/office/drawing/2014/main" id="{D6274432-845F-47D2-B152-B68CEB1BFE0E}"/>
+                <a16:creationId xmlns:a16="http://schemas.microsoft.com/office/drawing/2014/main" id="{37B2B098-C489-4A83-9E9A-77D91C6A2EA6}"/>
               </a:ext>
             </a:extLst>
           </p:cNvPr>
@@ -3771,7 +3776,7 @@
           <p:cNvPr id="67" name="pack-signature">
             <a:extLst xmlns:a="http://schemas.openxmlformats.org/drawingml/2006/main">
               <a:ext uri="{FF2B5EF4-FFF2-40B4-BE49-F238E27FC236}">
-                <a16:creationId xmlns:a16="http://schemas.microsoft.com/office/drawing/2014/main" id="{5870AC0A-152F-4B63-A7BB-D3C324BF6B25}"/>
+                <a16:creationId xmlns:a16="http://schemas.microsoft.com/office/drawing/2014/main" id="{E37F1722-FC3E-40FE-AEF1-8CA420D48F16}"/>
               </a:ext>
             </a:extLst>
           </p:cNvPr>
@@ -3816,7 +3821,7 @@
           <p:cNvPr id="68" name="verify-panel">
             <a:extLst xmlns:a="http://schemas.openxmlformats.org/drawingml/2006/main">
               <a:ext uri="{FF2B5EF4-FFF2-40B4-BE49-F238E27FC236}">
-                <a16:creationId xmlns:a16="http://schemas.microsoft.com/office/drawing/2014/main" id="{E4894DB3-89AE-44C0-82E8-318A2C51A792}"/>
+                <a16:creationId xmlns:a16="http://schemas.microsoft.com/office/drawing/2014/main" id="{7742B060-9D52-4E1B-88A1-4AA1BEA7218C}"/>
               </a:ext>
             </a:extLst>
           </p:cNvPr>
@@ -3849,7 +3854,7 @@
           <p:cNvPr id="69" name="verify-accent">
             <a:extLst xmlns:a="http://schemas.openxmlformats.org/drawingml/2006/main">
               <a:ext uri="{FF2B5EF4-FFF2-40B4-BE49-F238E27FC236}">
-                <a16:creationId xmlns:a16="http://schemas.microsoft.com/office/drawing/2014/main" id="{791ABE4F-2867-44EF-B356-8405A6DB3BB8}"/>
+                <a16:creationId xmlns:a16="http://schemas.microsoft.com/office/drawing/2014/main" id="{3DF512E0-663A-42C8-8C00-213E2C23448B}"/>
               </a:ext>
             </a:extLst>
           </p:cNvPr>
@@ -3882,7 +3887,7 @@
           <p:cNvPr id="70" name="verify-plane">
             <a:extLst xmlns:a="http://schemas.openxmlformats.org/drawingml/2006/main">
               <a:ext uri="{FF2B5EF4-FFF2-40B4-BE49-F238E27FC236}">
-                <a16:creationId xmlns:a16="http://schemas.microsoft.com/office/drawing/2014/main" id="{4D97FE25-46AD-46F9-AFAF-9CE297B86712}"/>
+                <a16:creationId xmlns:a16="http://schemas.microsoft.com/office/drawing/2014/main" id="{2CF69673-6B70-4445-829C-3BC7BBA04904}"/>
               </a:ext>
             </a:extLst>
           </p:cNvPr>
@@ -3927,7 +3932,7 @@
           <p:cNvPr id="71" name="verify-title">
             <a:extLst xmlns:a="http://schemas.openxmlformats.org/drawingml/2006/main">
               <a:ext uri="{FF2B5EF4-FFF2-40B4-BE49-F238E27FC236}">
-                <a16:creationId xmlns:a16="http://schemas.microsoft.com/office/drawing/2014/main" id="{C7318A62-86BB-421C-8356-79EBE26789E0}"/>
+                <a16:creationId xmlns:a16="http://schemas.microsoft.com/office/drawing/2014/main" id="{723138DC-C0D7-4098-ABC0-D8C3B04B09AB}"/>
               </a:ext>
             </a:extLst>
           </p:cNvPr>
@@ -3972,7 +3977,7 @@
           <p:cNvPr id="72" name="verify-key-dot">
             <a:extLst xmlns:a="http://schemas.openxmlformats.org/drawingml/2006/main">
               <a:ext uri="{FF2B5EF4-FFF2-40B4-BE49-F238E27FC236}">
-                <a16:creationId xmlns:a16="http://schemas.microsoft.com/office/drawing/2014/main" id="{9C6D5B23-DFC1-4342-95B8-5D1B40B02824}"/>
+                <a16:creationId xmlns:a16="http://schemas.microsoft.com/office/drawing/2014/main" id="{0D5AF3D7-E136-4838-8CC0-443586F71AC7}"/>
               </a:ext>
             </a:extLst>
           </p:cNvPr>
@@ -4005,7 +4010,7 @@
           <p:cNvPr id="73" name="verify-key-text">
             <a:extLst xmlns:a="http://schemas.openxmlformats.org/drawingml/2006/main">
               <a:ext uri="{FF2B5EF4-FFF2-40B4-BE49-F238E27FC236}">
-                <a16:creationId xmlns:a16="http://schemas.microsoft.com/office/drawing/2014/main" id="{6472878B-3C07-42E7-9EC1-AFAB1C6B95EC}"/>
+                <a16:creationId xmlns:a16="http://schemas.microsoft.com/office/drawing/2014/main" id="{9C3B3E6C-A27B-4E0F-8AFD-CD46FBE9F634}"/>
               </a:ext>
             </a:extLst>
           </p:cNvPr>
@@ -4017,15 +4022,15 @@
         <p:spPr>
           <a:xfrm xmlns:a="http://schemas.openxmlformats.org/drawingml/2006/main">
             <a:off x="8010525" y="5219700"/>
-            <a:ext cx="3438525" cy="257175"/>
-          </a:xfrm>
-          <a:prstGeom xmlns:a="http://schemas.openxmlformats.org/drawingml/2006/main" prst="rect">
-            <a:avLst/>
-          </a:prstGeom>
-        </p:spPr>
-        <p:txBody>
-          <a:bodyPr xmlns:a="http://schemas.openxmlformats.org/drawingml/2006/main" lIns="0" tIns="0" rIns="0" bIns="0" anchor="ctr">
-            <a:normAutofit fontScale="100000"/>
+            <a:ext cx="3438525" cy="333375"/>
+          </a:xfrm>
+          <a:prstGeom xmlns:a="http://schemas.openxmlformats.org/drawingml/2006/main" prst="rect">
+            <a:avLst/>
+          </a:prstGeom>
+        </p:spPr>
+        <p:txBody>
+          <a:bodyPr xmlns:a="http://schemas.openxmlformats.org/drawingml/2006/main" lIns="0" tIns="0" rIns="0" bIns="0" anchor="ctr">
+            <a:normAutofit fontScale="97222"/>
           </a:bodyPr>
           <a:lstStyle xmlns:a="http://schemas.openxmlformats.org/drawingml/2006/main"/>
           <a:p xmlns:a="http://schemas.openxmlformats.org/drawingml/2006/main">
@@ -4040,7 +4045,8 @@
               </a:defRPr>
             </a:pPr>
             <a:r>
-              <a:t>Pin key from KEYS.md and its mirror</a:t>
+              <a:t>Pin the public key out-of-band
+from KEYS.md or its mirror</a:t>
             </a:r>
           </a:p>
         </p:txBody>
@@ -4050,18 +4056,18 @@
           <p:cNvPr id="74" name="verify-manifest-dot">
             <a:extLst xmlns:a="http://schemas.openxmlformats.org/drawingml/2006/main">
               <a:ext uri="{FF2B5EF4-FFF2-40B4-BE49-F238E27FC236}">
-                <a16:creationId xmlns:a16="http://schemas.microsoft.com/office/drawing/2014/main" id="{A61847D5-5563-4993-B41C-580622B03A50}"/>
-              </a:ext>
-            </a:extLst>
-          </p:cNvPr>
-          <p:cNvSpPr>
-            <a:spLocks xmlns:a="http://schemas.openxmlformats.org/drawingml/2006/main" noGrp="1"/>
-          </p:cNvSpPr>
-          <p:nvPr/>
-        </p:nvSpPr>
-        <p:spPr>
-          <a:xfrm xmlns:a="http://schemas.openxmlformats.org/drawingml/2006/main">
-            <a:off x="7848600" y="5562600"/>
+                <a16:creationId xmlns:a16="http://schemas.microsoft.com/office/drawing/2014/main" id="{75D47D06-AC54-449A-8BAF-7FECAF8E94C2}"/>
+              </a:ext>
+            </a:extLst>
+          </p:cNvPr>
+          <p:cNvSpPr>
+            <a:spLocks xmlns:a="http://schemas.openxmlformats.org/drawingml/2006/main" noGrp="1"/>
+          </p:cNvSpPr>
+          <p:nvPr/>
+        </p:nvSpPr>
+        <p:spPr>
+          <a:xfrm xmlns:a="http://schemas.openxmlformats.org/drawingml/2006/main">
+            <a:off x="7848600" y="5648325"/>
             <a:ext cx="66675" cy="66675"/>
           </a:xfrm>
           <a:prstGeom xmlns:a="http://schemas.openxmlformats.org/drawingml/2006/main" prst="ellipse">
@@ -4083,18 +4089,18 @@
           <p:cNvPr id="75" name="verify-manifest-text">
             <a:extLst xmlns:a="http://schemas.openxmlformats.org/drawingml/2006/main">
               <a:ext uri="{FF2B5EF4-FFF2-40B4-BE49-F238E27FC236}">
-                <a16:creationId xmlns:a16="http://schemas.microsoft.com/office/drawing/2014/main" id="{33AB2685-7F2C-43D7-A5D1-A1B05256E02A}"/>
-              </a:ext>
-            </a:extLst>
-          </p:cNvPr>
-          <p:cNvSpPr>
-            <a:spLocks xmlns:a="http://schemas.openxmlformats.org/drawingml/2006/main" noGrp="1"/>
-          </p:cNvSpPr>
-          <p:nvPr/>
-        </p:nvSpPr>
-        <p:spPr>
-          <a:xfrm xmlns:a="http://schemas.openxmlformats.org/drawingml/2006/main">
-            <a:off x="8010525" y="5486400"/>
+                <a16:creationId xmlns:a16="http://schemas.microsoft.com/office/drawing/2014/main" id="{9835DF57-FFCE-40C6-95CA-2B79C5FC08D9}"/>
+              </a:ext>
+            </a:extLst>
+          </p:cNvPr>
+          <p:cNvSpPr>
+            <a:spLocks xmlns:a="http://schemas.openxmlformats.org/drawingml/2006/main" noGrp="1"/>
+          </p:cNvSpPr>
+          <p:nvPr/>
+        </p:nvSpPr>
+        <p:spPr>
+          <a:xfrm xmlns:a="http://schemas.openxmlformats.org/drawingml/2006/main">
+            <a:off x="8010525" y="5572125"/>
             <a:ext cx="3438525" cy="257175"/>
           </a:xfrm>
           <a:prstGeom xmlns:a="http://schemas.openxmlformats.org/drawingml/2006/main" prst="rect">
@@ -4128,32 +4134,32 @@
           <p:cNvPr id="76" name="verify-final">
             <a:extLst xmlns:a="http://schemas.openxmlformats.org/drawingml/2006/main">
               <a:ext uri="{FF2B5EF4-FFF2-40B4-BE49-F238E27FC236}">
-                <a16:creationId xmlns:a16="http://schemas.microsoft.com/office/drawing/2014/main" id="{C6E8F0DF-ED64-41A9-996F-A3590AF996C4}"/>
-              </a:ext>
-            </a:extLst>
-          </p:cNvPr>
-          <p:cNvSpPr>
-            <a:spLocks xmlns:a="http://schemas.openxmlformats.org/drawingml/2006/main" noGrp="1"/>
-          </p:cNvSpPr>
-          <p:nvPr/>
-        </p:nvSpPr>
-        <p:spPr>
-          <a:xfrm xmlns:a="http://schemas.openxmlformats.org/drawingml/2006/main">
-            <a:off x="7848600" y="5762625"/>
-            <a:ext cx="3600450" cy="219075"/>
-          </a:xfrm>
-          <a:prstGeom xmlns:a="http://schemas.openxmlformats.org/drawingml/2006/main" prst="rect">
-            <a:avLst/>
-          </a:prstGeom>
-        </p:spPr>
-        <p:txBody>
-          <a:bodyPr xmlns:a="http://schemas.openxmlformats.org/drawingml/2006/main" lIns="0" tIns="0" rIns="0" bIns="0" anchor="ctr">
-            <a:normAutofit fontScale="70953"/>
+                <a16:creationId xmlns:a16="http://schemas.microsoft.com/office/drawing/2014/main" id="{DA647078-E27A-403F-8453-02E06C94177F}"/>
+              </a:ext>
+            </a:extLst>
+          </p:cNvPr>
+          <p:cNvSpPr>
+            <a:spLocks xmlns:a="http://schemas.openxmlformats.org/drawingml/2006/main" noGrp="1"/>
+          </p:cNvSpPr>
+          <p:nvPr/>
+        </p:nvSpPr>
+        <p:spPr>
+          <a:xfrm xmlns:a="http://schemas.openxmlformats.org/drawingml/2006/main">
+            <a:off x="7848600" y="5838825"/>
+            <a:ext cx="3600450" cy="161925"/>
+          </a:xfrm>
+          <a:prstGeom xmlns:a="http://schemas.openxmlformats.org/drawingml/2006/main" prst="rect">
+            <a:avLst/>
+          </a:prstGeom>
+        </p:spPr>
+        <p:txBody>
+          <a:bodyPr xmlns:a="http://schemas.openxmlformats.org/drawingml/2006/main" lIns="0" tIns="0" rIns="0" bIns="0" anchor="ctr">
+            <a:normAutofit fontScale="65881"/>
           </a:bodyPr>
           <a:lstStyle xmlns:a="http://schemas.openxmlformats.org/drawingml/2006/main"/>
           <a:p xmlns:a="http://schemas.openxmlformats.org/drawingml/2006/main">
             <a:pPr algn="l">
-              <a:defRPr sz="1013" b="1">
+              <a:defRPr sz="938" b="1">
                 <a:solidFill>
                   <a:srgbClr val="0D5D48"/>
                 </a:solidFill>
@@ -4173,7 +4179,7 @@
           <p:cNvPr id="77" name="architecture-boundary">
             <a:extLst xmlns:a="http://schemas.openxmlformats.org/drawingml/2006/main">
               <a:ext uri="{FF2B5EF4-FFF2-40B4-BE49-F238E27FC236}">
-                <a16:creationId xmlns:a16="http://schemas.microsoft.com/office/drawing/2014/main" id="{351DF189-B320-45D5-85F0-04317F5B7510}"/>
+                <a16:creationId xmlns:a16="http://schemas.microsoft.com/office/drawing/2014/main" id="{780EC1DF-E155-4337-A62E-16216C8DFD89}"/>
               </a:ext>
             </a:extLst>
           </p:cNvPr>
@@ -4218,7 +4224,7 @@
           <p:cNvPr id="78" name="source-footer">
             <a:extLst xmlns:a="http://schemas.openxmlformats.org/drawingml/2006/main">
               <a:ext uri="{FF2B5EF4-FFF2-40B4-BE49-F238E27FC236}">
-                <a16:creationId xmlns:a16="http://schemas.microsoft.com/office/drawing/2014/main" id="{48C23C5D-D667-49D2-98CB-32E9D36735E8}"/>
+                <a16:creationId xmlns:a16="http://schemas.microsoft.com/office/drawing/2014/main" id="{02866DBD-18D2-4D65-8268-D4F5D8699A8C}"/>
               </a:ext>
             </a:extLst>
           </p:cNvPr>
@@ -4263,7 +4269,7 @@
           <p:cNvPr id="79" name="slide-number">
             <a:extLst xmlns:a="http://schemas.openxmlformats.org/drawingml/2006/main">
               <a:ext uri="{FF2B5EF4-FFF2-40B4-BE49-F238E27FC236}">
-                <a16:creationId xmlns:a16="http://schemas.microsoft.com/office/drawing/2014/main" id="{99236A82-7201-4C52-A294-F476A5D34E48}"/>
+                <a16:creationId xmlns:a16="http://schemas.microsoft.com/office/drawing/2014/main" id="{C7C92960-AF5E-45F7-8C90-E35CC2AE1A90}"/>
               </a:ext>
             </a:extLst>
           </p:cNvPr>
@@ -4306,7 +4312,7 @@
     </p:spTree>
     <p:extLst>
       <p:ext uri="{BB962C8B-B14F-4D97-AF65-F5344CB8AC3E}">
-        <p14:creationId xmlns:p14="http://schemas.microsoft.com/office/powerpoint/2010/main" val="508505466"/>
+        <p14:creationId xmlns:p14="http://schemas.microsoft.com/office/powerpoint/2010/main" val="1605925774"/>
       </p:ext>
     </p:extLst>
   </p:cSld>

</xml_diff>

<commit_message>
Clarify conditional audit ID callback
</commit_message>
<xml_diff>
--- a/outputs/cordant_inntris_architecture.pptx
+++ b/outputs/cordant_inntris_architecture.pptx
@@ -2,13 +2,13 @@
 <file path=ppt/presentation.xml><?xml version="1.0" encoding="utf-8"?>
 <p:presentation xmlns:p="http://schemas.openxmlformats.org/presentationml/2006/main">
   <p:sldMasterIdLst>
-    <p:sldMasterId xmlns:r="http://schemas.openxmlformats.org/officeDocument/2006/relationships" id="2147483648" r:id="Ra848af1c9a5e46db"/>
+    <p:sldMasterId xmlns:r="http://schemas.openxmlformats.org/officeDocument/2006/relationships" id="2147483648" r:id="Rad369d8737c8405a"/>
   </p:sldMasterIdLst>
   <p:notesMasterIdLst>
-    <p:notesMasterId xmlns:r="http://schemas.openxmlformats.org/officeDocument/2006/relationships" r:id="Rbdba1fa3f7b94aa1"/>
+    <p:notesMasterId xmlns:r="http://schemas.openxmlformats.org/officeDocument/2006/relationships" r:id="Rcb47ebe1e7c648f3"/>
   </p:notesMasterIdLst>
   <p:sldIdLst>
-    <p:sldId xmlns:r="http://schemas.openxmlformats.org/officeDocument/2006/relationships" id="256" r:id="Rb338a17ebf2e4994"/>
+    <p:sldId xmlns:r="http://schemas.openxmlformats.org/officeDocument/2006/relationships" id="256" r:id="R939025f3ca6b4578"/>
   </p:sldIdLst>
   <p:sldSz cx="12192000" cy="6858000"/>
   <p:notesSz cx="6858000" cy="9144000"/>
@@ -601,7 +601,7 @@
   </p:cSld>
   <p:clrMap bg1="lt1" tx1="dk1" bg2="lt2" tx2="dk2" accent1="accent1" accent2="accent2" accent3="accent3" accent4="accent4" accent5="accent5" accent6="accent6" hlink="hlink" folHlink="folHlink"/>
   <p:sldLayoutIdLst>
-    <p:sldLayoutId xmlns:r="http://schemas.openxmlformats.org/officeDocument/2006/relationships" id="2147483649" r:id="Ra1a4542ff3454d0e"/>
+    <p:sldLayoutId xmlns:r="http://schemas.openxmlformats.org/officeDocument/2006/relationships" id="2147483649" r:id="Re92023111a154f7a"/>
   </p:sldLayoutIdLst>
   <p:txStyles>
     <p:titleStyle>
@@ -1145,7 +1145,7 @@
           <p:cNvPr id="80" name="canvas">
             <a:extLst xmlns:a="http://schemas.openxmlformats.org/drawingml/2006/main">
               <a:ext uri="{FF2B5EF4-FFF2-40B4-BE49-F238E27FC236}">
-                <a16:creationId xmlns:a16="http://schemas.microsoft.com/office/drawing/2014/main" id="{5A7FE704-0049-422D-9D29-587096EC1FCA}"/>
+                <a16:creationId xmlns:a16="http://schemas.microsoft.com/office/drawing/2014/main" id="{F20A66C2-9082-4A84-AC85-0D296A12B2D8}"/>
               </a:ext>
             </a:extLst>
           </p:cNvPr>
@@ -1178,7 +1178,7 @@
           <p:cNvPr id="2" name="eyebrow">
             <a:extLst xmlns:a="http://schemas.openxmlformats.org/drawingml/2006/main">
               <a:ext uri="{FF2B5EF4-FFF2-40B4-BE49-F238E27FC236}">
-                <a16:creationId xmlns:a16="http://schemas.microsoft.com/office/drawing/2014/main" id="{6E8124C3-7E17-41C5-921F-601175850AE6}"/>
+                <a16:creationId xmlns:a16="http://schemas.microsoft.com/office/drawing/2014/main" id="{B0D0F839-9504-4023-8DFC-B03B886747A6}"/>
               </a:ext>
             </a:extLst>
           </p:cNvPr>
@@ -1223,7 +1223,7 @@
           <p:cNvPr id="3" name="headline">
             <a:extLst xmlns:a="http://schemas.openxmlformats.org/drawingml/2006/main">
               <a:ext uri="{FF2B5EF4-FFF2-40B4-BE49-F238E27FC236}">
-                <a16:creationId xmlns:a16="http://schemas.microsoft.com/office/drawing/2014/main" id="{CD784A14-1F48-478D-9509-212ECE39E07A}"/>
+                <a16:creationId xmlns:a16="http://schemas.microsoft.com/office/drawing/2014/main" id="{AF45BE50-89E1-47F5-BCFF-B249D9FC6964}"/>
               </a:ext>
             </a:extLst>
           </p:cNvPr>
@@ -1269,7 +1269,7 @@
           <p:cNvPr id="4" name="subhead">
             <a:extLst xmlns:a="http://schemas.openxmlformats.org/drawingml/2006/main">
               <a:ext uri="{FF2B5EF4-FFF2-40B4-BE49-F238E27FC236}">
-                <a16:creationId xmlns:a16="http://schemas.microsoft.com/office/drawing/2014/main" id="{BFE5D7EF-36F4-4E1C-9108-DF9E4223BBE5}"/>
+                <a16:creationId xmlns:a16="http://schemas.microsoft.com/office/drawing/2014/main" id="{35E63D06-6195-4094-8A0A-AB8FAEA7DB69}"/>
               </a:ext>
             </a:extLst>
           </p:cNvPr>
@@ -1337,7 +1337,7 @@
           <p:cNvPr id="6" name="intent-flow-caption">
             <a:extLst xmlns:a="http://schemas.openxmlformats.org/drawingml/2006/main">
               <a:ext uri="{FF2B5EF4-FFF2-40B4-BE49-F238E27FC236}">
-                <a16:creationId xmlns:a16="http://schemas.microsoft.com/office/drawing/2014/main" id="{E7964F7B-A60F-44B9-A98F-338E4FBF54EF}"/>
+                <a16:creationId xmlns:a16="http://schemas.microsoft.com/office/drawing/2014/main" id="{D10FA7C1-7B22-48A1-80AD-A859A0CCB79B}"/>
               </a:ext>
             </a:extLst>
           </p:cNvPr>
@@ -1383,7 +1383,7 @@
           <p:cNvPr id="7" name="intent-flow-arrow">
             <a:extLst xmlns:a="http://schemas.openxmlformats.org/drawingml/2006/main">
               <a:ext uri="{FF2B5EF4-FFF2-40B4-BE49-F238E27FC236}">
-                <a16:creationId xmlns:a16="http://schemas.microsoft.com/office/drawing/2014/main" id="{23AC2BB5-E7A2-42F7-A8D1-0E94D5620CE3}"/>
+                <a16:creationId xmlns:a16="http://schemas.microsoft.com/office/drawing/2014/main" id="{9A871E9A-FA22-420A-B192-A9163582F136}"/>
               </a:ext>
             </a:extLst>
           </p:cNvPr>
@@ -1428,7 +1428,7 @@
           <p:cNvPr id="8" name="decision-flow-caption">
             <a:extLst xmlns:a="http://schemas.openxmlformats.org/drawingml/2006/main">
               <a:ext uri="{FF2B5EF4-FFF2-40B4-BE49-F238E27FC236}">
-                <a16:creationId xmlns:a16="http://schemas.microsoft.com/office/drawing/2014/main" id="{418718AC-1B8F-45F1-95C9-C49EC3D2CD83}"/>
+                <a16:creationId xmlns:a16="http://schemas.microsoft.com/office/drawing/2014/main" id="{CA6B8578-CBB4-4712-9A9E-C6A5E61CADA2}"/>
               </a:ext>
             </a:extLst>
           </p:cNvPr>
@@ -1474,7 +1474,7 @@
           <p:cNvPr id="9" name="decision-flow-arrow">
             <a:extLst xmlns:a="http://schemas.openxmlformats.org/drawingml/2006/main">
               <a:ext uri="{FF2B5EF4-FFF2-40B4-BE49-F238E27FC236}">
-                <a16:creationId xmlns:a16="http://schemas.microsoft.com/office/drawing/2014/main" id="{885F9BDF-6178-4F35-B16F-3C24106450BB}"/>
+                <a16:creationId xmlns:a16="http://schemas.microsoft.com/office/drawing/2014/main" id="{25D65177-554F-4BBD-AF86-BC2D84AFBBF5}"/>
               </a:ext>
             </a:extLst>
           </p:cNvPr>
@@ -1519,7 +1519,7 @@
           <p:cNvPr id="10" name="cordant-panel">
             <a:extLst xmlns:a="http://schemas.openxmlformats.org/drawingml/2006/main">
               <a:ext uri="{FF2B5EF4-FFF2-40B4-BE49-F238E27FC236}">
-                <a16:creationId xmlns:a16="http://schemas.microsoft.com/office/drawing/2014/main" id="{0439DE9A-9C95-4AD0-B8C5-2A1B84B62FA4}"/>
+                <a16:creationId xmlns:a16="http://schemas.microsoft.com/office/drawing/2014/main" id="{ABEF3ACC-0579-446B-8FC6-27ED77A8C04F}"/>
               </a:ext>
             </a:extLst>
           </p:cNvPr>
@@ -1552,7 +1552,7 @@
           <p:cNvPr id="11" name="cordant-accent">
             <a:extLst xmlns:a="http://schemas.openxmlformats.org/drawingml/2006/main">
               <a:ext uri="{FF2B5EF4-FFF2-40B4-BE49-F238E27FC236}">
-                <a16:creationId xmlns:a16="http://schemas.microsoft.com/office/drawing/2014/main" id="{0DC2992C-DA79-4072-8806-AC6AB82393CB}"/>
+                <a16:creationId xmlns:a16="http://schemas.microsoft.com/office/drawing/2014/main" id="{65E1F1B9-EEDE-41EB-982C-F98D30ACBE8B}"/>
               </a:ext>
             </a:extLst>
           </p:cNvPr>
@@ -1585,7 +1585,7 @@
           <p:cNvPr id="12" name="cordant-plane">
             <a:extLst xmlns:a="http://schemas.openxmlformats.org/drawingml/2006/main">
               <a:ext uri="{FF2B5EF4-FFF2-40B4-BE49-F238E27FC236}">
-                <a16:creationId xmlns:a16="http://schemas.microsoft.com/office/drawing/2014/main" id="{D9A805EA-04B6-4B40-9926-306147C6FEE2}"/>
+                <a16:creationId xmlns:a16="http://schemas.microsoft.com/office/drawing/2014/main" id="{3B97A085-8722-4BDC-93A2-AA7B558F2F2B}"/>
               </a:ext>
             </a:extLst>
           </p:cNvPr>
@@ -1630,7 +1630,7 @@
           <p:cNvPr id="13" name="cordant-title">
             <a:extLst xmlns:a="http://schemas.openxmlformats.org/drawingml/2006/main">
               <a:ext uri="{FF2B5EF4-FFF2-40B4-BE49-F238E27FC236}">
-                <a16:creationId xmlns:a16="http://schemas.microsoft.com/office/drawing/2014/main" id="{5C832027-CE04-44F8-846F-AB51F7A3BC27}"/>
+                <a16:creationId xmlns:a16="http://schemas.microsoft.com/office/drawing/2014/main" id="{4C4A94CC-0DD1-428F-A67B-E60143D945E0}"/>
               </a:ext>
             </a:extLst>
           </p:cNvPr>
@@ -1697,7 +1697,7 @@
           <p:cNvPr id="15" name="cordant-connect-dot">
             <a:extLst xmlns:a="http://schemas.openxmlformats.org/drawingml/2006/main">
               <a:ext uri="{FF2B5EF4-FFF2-40B4-BE49-F238E27FC236}">
-                <a16:creationId xmlns:a16="http://schemas.microsoft.com/office/drawing/2014/main" id="{5829435B-9AFF-4911-A4CE-916DC9826E6C}"/>
+                <a16:creationId xmlns:a16="http://schemas.microsoft.com/office/drawing/2014/main" id="{1CE20C76-8987-45DE-B197-AA69281BC970}"/>
               </a:ext>
             </a:extLst>
           </p:cNvPr>
@@ -1730,7 +1730,7 @@
           <p:cNvPr id="16" name="cordant-connect-text">
             <a:extLst xmlns:a="http://schemas.openxmlformats.org/drawingml/2006/main">
               <a:ext uri="{FF2B5EF4-FFF2-40B4-BE49-F238E27FC236}">
-                <a16:creationId xmlns:a16="http://schemas.microsoft.com/office/drawing/2014/main" id="{8AE5867B-6E8A-4303-AFD7-E35DFC47296F}"/>
+                <a16:creationId xmlns:a16="http://schemas.microsoft.com/office/drawing/2014/main" id="{EDB983E8-3BF9-4217-9033-001E9CB7ED06}"/>
               </a:ext>
             </a:extLst>
           </p:cNvPr>
@@ -1775,7 +1775,7 @@
           <p:cNvPr id="17" name="cordant-normalise-dot">
             <a:extLst xmlns:a="http://schemas.openxmlformats.org/drawingml/2006/main">
               <a:ext uri="{FF2B5EF4-FFF2-40B4-BE49-F238E27FC236}">
-                <a16:creationId xmlns:a16="http://schemas.microsoft.com/office/drawing/2014/main" id="{9DCCD2A9-F862-4F74-947B-84B25F32E880}"/>
+                <a16:creationId xmlns:a16="http://schemas.microsoft.com/office/drawing/2014/main" id="{EB25A227-047B-42A1-8379-4ACC9A182AEA}"/>
               </a:ext>
             </a:extLst>
           </p:cNvPr>
@@ -1808,7 +1808,7 @@
           <p:cNvPr id="18" name="cordant-normalise-text">
             <a:extLst xmlns:a="http://schemas.openxmlformats.org/drawingml/2006/main">
               <a:ext uri="{FF2B5EF4-FFF2-40B4-BE49-F238E27FC236}">
-                <a16:creationId xmlns:a16="http://schemas.microsoft.com/office/drawing/2014/main" id="{205E1AC7-1532-47EA-BFF7-2AE90F2FC30F}"/>
+                <a16:creationId xmlns:a16="http://schemas.microsoft.com/office/drawing/2014/main" id="{2340829E-FFE6-4A74-BC24-B7E883C2FB15}"/>
               </a:ext>
             </a:extLst>
           </p:cNvPr>
@@ -1853,7 +1853,7 @@
           <p:cNvPr id="19" name="cordant-propose-dot">
             <a:extLst xmlns:a="http://schemas.openxmlformats.org/drawingml/2006/main">
               <a:ext uri="{FF2B5EF4-FFF2-40B4-BE49-F238E27FC236}">
-                <a16:creationId xmlns:a16="http://schemas.microsoft.com/office/drawing/2014/main" id="{0D6CAA68-DE2D-4BF5-8544-743B4605CC1E}"/>
+                <a16:creationId xmlns:a16="http://schemas.microsoft.com/office/drawing/2014/main" id="{D7575764-2FA5-46DD-A112-56B0ED633FE8}"/>
               </a:ext>
             </a:extLst>
           </p:cNvPr>
@@ -1886,7 +1886,7 @@
           <p:cNvPr id="20" name="cordant-propose-text">
             <a:extLst xmlns:a="http://schemas.openxmlformats.org/drawingml/2006/main">
               <a:ext uri="{FF2B5EF4-FFF2-40B4-BE49-F238E27FC236}">
-                <a16:creationId xmlns:a16="http://schemas.microsoft.com/office/drawing/2014/main" id="{7F9A7E0A-9BB1-43F1-9E4F-62620A6FF1EF}"/>
+                <a16:creationId xmlns:a16="http://schemas.microsoft.com/office/drawing/2014/main" id="{E8A3D3DC-5FCA-4E81-98FA-4785C52FB826}"/>
               </a:ext>
             </a:extLst>
           </p:cNvPr>
@@ -1931,7 +1931,7 @@
           <p:cNvPr id="21" name="cordant-boundary">
             <a:extLst xmlns:a="http://schemas.openxmlformats.org/drawingml/2006/main">
               <a:ext uri="{FF2B5EF4-FFF2-40B4-BE49-F238E27FC236}">
-                <a16:creationId xmlns:a16="http://schemas.microsoft.com/office/drawing/2014/main" id="{17F05388-39AF-4DE7-B1B2-1284625E6704}"/>
+                <a16:creationId xmlns:a16="http://schemas.microsoft.com/office/drawing/2014/main" id="{8E652715-C645-4FA8-96D4-C17C8285F4A3}"/>
               </a:ext>
             </a:extLst>
           </p:cNvPr>
@@ -1976,7 +1976,7 @@
           <p:cNvPr id="22" name="mtp-panel">
             <a:extLst xmlns:a="http://schemas.openxmlformats.org/drawingml/2006/main">
               <a:ext uri="{FF2B5EF4-FFF2-40B4-BE49-F238E27FC236}">
-                <a16:creationId xmlns:a16="http://schemas.microsoft.com/office/drawing/2014/main" id="{105203A7-4BCE-40DF-854C-D9EBAE8933EA}"/>
+                <a16:creationId xmlns:a16="http://schemas.microsoft.com/office/drawing/2014/main" id="{2F63FFB3-069A-4A2E-B48D-9ED6C45C2B2C}"/>
               </a:ext>
             </a:extLst>
           </p:cNvPr>
@@ -2009,7 +2009,7 @@
           <p:cNvPr id="23" name="mtp-accent">
             <a:extLst xmlns:a="http://schemas.openxmlformats.org/drawingml/2006/main">
               <a:ext uri="{FF2B5EF4-FFF2-40B4-BE49-F238E27FC236}">
-                <a16:creationId xmlns:a16="http://schemas.microsoft.com/office/drawing/2014/main" id="{FB9D8840-970F-44C7-9AB0-52A8C23E37B4}"/>
+                <a16:creationId xmlns:a16="http://schemas.microsoft.com/office/drawing/2014/main" id="{9ECB465B-A68E-43BD-8123-11FA5FEF8253}"/>
               </a:ext>
             </a:extLst>
           </p:cNvPr>
@@ -2042,7 +2042,7 @@
           <p:cNvPr id="24" name="mtp-plane">
             <a:extLst xmlns:a="http://schemas.openxmlformats.org/drawingml/2006/main">
               <a:ext uri="{FF2B5EF4-FFF2-40B4-BE49-F238E27FC236}">
-                <a16:creationId xmlns:a16="http://schemas.microsoft.com/office/drawing/2014/main" id="{FFFF4F79-EA51-4AB3-A8D7-1B527423A956}"/>
+                <a16:creationId xmlns:a16="http://schemas.microsoft.com/office/drawing/2014/main" id="{BABB6E94-6B8D-41BF-A572-A4357FFEAE47}"/>
               </a:ext>
             </a:extLst>
           </p:cNvPr>
@@ -2087,7 +2087,7 @@
           <p:cNvPr id="25" name="mtp-title">
             <a:extLst xmlns:a="http://schemas.openxmlformats.org/drawingml/2006/main">
               <a:ext uri="{FF2B5EF4-FFF2-40B4-BE49-F238E27FC236}">
-                <a16:creationId xmlns:a16="http://schemas.microsoft.com/office/drawing/2014/main" id="{17B4F8FE-A969-481B-873F-8742CEF86F89}"/>
+                <a16:creationId xmlns:a16="http://schemas.microsoft.com/office/drawing/2014/main" id="{4CEB66CC-76CE-4C00-805B-3B72EA828301}"/>
               </a:ext>
             </a:extLst>
           </p:cNvPr>
@@ -2154,7 +2154,7 @@
           <p:cNvPr id="27" name="mtp-route-dot">
             <a:extLst xmlns:a="http://schemas.openxmlformats.org/drawingml/2006/main">
               <a:ext uri="{FF2B5EF4-FFF2-40B4-BE49-F238E27FC236}">
-                <a16:creationId xmlns:a16="http://schemas.microsoft.com/office/drawing/2014/main" id="{D8088DBC-A855-4BF2-BAD8-8B8C8B1E1888}"/>
+                <a16:creationId xmlns:a16="http://schemas.microsoft.com/office/drawing/2014/main" id="{156DF979-F978-4A99-B7C6-E7C40CF937FB}"/>
               </a:ext>
             </a:extLst>
           </p:cNvPr>
@@ -2187,7 +2187,7 @@
           <p:cNvPr id="28" name="mtp-route-text">
             <a:extLst xmlns:a="http://schemas.openxmlformats.org/drawingml/2006/main">
               <a:ext uri="{FF2B5EF4-FFF2-40B4-BE49-F238E27FC236}">
-                <a16:creationId xmlns:a16="http://schemas.microsoft.com/office/drawing/2014/main" id="{A07FEA7C-DF18-4C5F-9A48-C93E6F16AA5A}"/>
+                <a16:creationId xmlns:a16="http://schemas.microsoft.com/office/drawing/2014/main" id="{FAD79975-9A7E-4BCA-8B8F-2CB896EA3E31}"/>
               </a:ext>
             </a:extLst>
           </p:cNvPr>
@@ -2232,7 +2232,7 @@
           <p:cNvPr id="29" name="mtp-checks-dot">
             <a:extLst xmlns:a="http://schemas.openxmlformats.org/drawingml/2006/main">
               <a:ext uri="{FF2B5EF4-FFF2-40B4-BE49-F238E27FC236}">
-                <a16:creationId xmlns:a16="http://schemas.microsoft.com/office/drawing/2014/main" id="{349D847D-E1AB-43F9-BCEC-22E0AFFD76A6}"/>
+                <a16:creationId xmlns:a16="http://schemas.microsoft.com/office/drawing/2014/main" id="{D6DD7570-225C-4DDB-A5A6-1616659EE312}"/>
               </a:ext>
             </a:extLst>
           </p:cNvPr>
@@ -2265,7 +2265,7 @@
           <p:cNvPr id="30" name="mtp-checks-text">
             <a:extLst xmlns:a="http://schemas.openxmlformats.org/drawingml/2006/main">
               <a:ext uri="{FF2B5EF4-FFF2-40B4-BE49-F238E27FC236}">
-                <a16:creationId xmlns:a16="http://schemas.microsoft.com/office/drawing/2014/main" id="{AE2EBB54-CC26-4AE7-9772-160C85E6BEF7}"/>
+                <a16:creationId xmlns:a16="http://schemas.microsoft.com/office/drawing/2014/main" id="{06EB2D9B-6763-45FB-B367-1DE4F3ED9C1B}"/>
               </a:ext>
             </a:extLst>
           </p:cNvPr>
@@ -2310,7 +2310,7 @@
           <p:cNvPr id="31" name="mtp-decision-dot">
             <a:extLst xmlns:a="http://schemas.openxmlformats.org/drawingml/2006/main">
               <a:ext uri="{FF2B5EF4-FFF2-40B4-BE49-F238E27FC236}">
-                <a16:creationId xmlns:a16="http://schemas.microsoft.com/office/drawing/2014/main" id="{212E3F1E-B11E-441C-A15A-011C671089C0}"/>
+                <a16:creationId xmlns:a16="http://schemas.microsoft.com/office/drawing/2014/main" id="{5551B488-821B-4D19-BDBB-5F4FD9EE3C16}"/>
               </a:ext>
             </a:extLst>
           </p:cNvPr>
@@ -2343,7 +2343,7 @@
           <p:cNvPr id="32" name="mtp-decision-text">
             <a:extLst xmlns:a="http://schemas.openxmlformats.org/drawingml/2006/main">
               <a:ext uri="{FF2B5EF4-FFF2-40B4-BE49-F238E27FC236}">
-                <a16:creationId xmlns:a16="http://schemas.microsoft.com/office/drawing/2014/main" id="{BC459645-3B05-44CA-B58D-5C1D8EEFFD46}"/>
+                <a16:creationId xmlns:a16="http://schemas.microsoft.com/office/drawing/2014/main" id="{5843846E-4EBF-4C69-9DB8-C0D144193C5D}"/>
               </a:ext>
             </a:extLst>
           </p:cNvPr>
@@ -2388,7 +2388,7 @@
           <p:cNvPr id="33" name="mtp-invalid">
             <a:extLst xmlns:a="http://schemas.openxmlformats.org/drawingml/2006/main">
               <a:ext uri="{FF2B5EF4-FFF2-40B4-BE49-F238E27FC236}">
-                <a16:creationId xmlns:a16="http://schemas.microsoft.com/office/drawing/2014/main" id="{C2849EA3-FAE8-48FF-A62C-D185283C70E9}"/>
+                <a16:creationId xmlns:a16="http://schemas.microsoft.com/office/drawing/2014/main" id="{44CBD980-28F1-4DE4-B8AC-ADF9EDC3E29D}"/>
               </a:ext>
             </a:extLst>
           </p:cNvPr>
@@ -2433,7 +2433,7 @@
           <p:cNvPr id="34" name="execution-panel">
             <a:extLst xmlns:a="http://schemas.openxmlformats.org/drawingml/2006/main">
               <a:ext uri="{FF2B5EF4-FFF2-40B4-BE49-F238E27FC236}">
-                <a16:creationId xmlns:a16="http://schemas.microsoft.com/office/drawing/2014/main" id="{4069CA67-DFBA-445A-8DE0-967F0AF7D3D5}"/>
+                <a16:creationId xmlns:a16="http://schemas.microsoft.com/office/drawing/2014/main" id="{42556B3B-027F-40F4-8F20-0793F9CD3F95}"/>
               </a:ext>
             </a:extLst>
           </p:cNvPr>
@@ -2466,7 +2466,7 @@
           <p:cNvPr id="35" name="execution-plane">
             <a:extLst xmlns:a="http://schemas.openxmlformats.org/drawingml/2006/main">
               <a:ext uri="{FF2B5EF4-FFF2-40B4-BE49-F238E27FC236}">
-                <a16:creationId xmlns:a16="http://schemas.microsoft.com/office/drawing/2014/main" id="{5D590DE4-E06D-401E-83F7-2CE87C547066}"/>
+                <a16:creationId xmlns:a16="http://schemas.microsoft.com/office/drawing/2014/main" id="{B3CBE287-53BC-4897-8E28-B88159A1D608}"/>
               </a:ext>
             </a:extLst>
           </p:cNvPr>
@@ -2511,7 +2511,7 @@
           <p:cNvPr id="36" name="execution-title">
             <a:extLst xmlns:a="http://schemas.openxmlformats.org/drawingml/2006/main">
               <a:ext uri="{FF2B5EF4-FFF2-40B4-BE49-F238E27FC236}">
-                <a16:creationId xmlns:a16="http://schemas.microsoft.com/office/drawing/2014/main" id="{95E6FDC1-0EBA-48B6-A6A3-025BB928B3FA}"/>
+                <a16:creationId xmlns:a16="http://schemas.microsoft.com/office/drawing/2014/main" id="{8EDBBBF9-2413-4463-A205-9231D4F9B146}"/>
               </a:ext>
             </a:extLst>
           </p:cNvPr>
@@ -2578,7 +2578,7 @@
           <p:cNvPr id="38" name="execution-route">
             <a:extLst xmlns:a="http://schemas.openxmlformats.org/drawingml/2006/main">
               <a:ext uri="{FF2B5EF4-FFF2-40B4-BE49-F238E27FC236}">
-                <a16:creationId xmlns:a16="http://schemas.microsoft.com/office/drawing/2014/main" id="{A9D84C84-BEB6-47FB-A238-D5263461BD4F}"/>
+                <a16:creationId xmlns:a16="http://schemas.microsoft.com/office/drawing/2014/main" id="{EF80B0C7-088F-4177-A18D-13CAC130934B}"/>
               </a:ext>
             </a:extLst>
           </p:cNvPr>
@@ -2623,7 +2623,7 @@
           <p:cNvPr id="39" name="execution-inputs">
             <a:extLst xmlns:a="http://schemas.openxmlformats.org/drawingml/2006/main">
               <a:ext uri="{FF2B5EF4-FFF2-40B4-BE49-F238E27FC236}">
-                <a16:creationId xmlns:a16="http://schemas.microsoft.com/office/drawing/2014/main" id="{383300A1-BD1C-41E1-BF2C-ED0E0D20C761}"/>
+                <a16:creationId xmlns:a16="http://schemas.microsoft.com/office/drawing/2014/main" id="{6282DC5E-9711-403A-86D8-71FF53005080}"/>
               </a:ext>
             </a:extLst>
           </p:cNvPr>
@@ -2668,7 +2668,7 @@
           <p:cNvPr id="40" name="execution-proceed">
             <a:extLst xmlns:a="http://schemas.openxmlformats.org/drawingml/2006/main">
               <a:ext uri="{FF2B5EF4-FFF2-40B4-BE49-F238E27FC236}">
-                <a16:creationId xmlns:a16="http://schemas.microsoft.com/office/drawing/2014/main" id="{98912F8E-BFE6-47A2-AEBC-C8E34EDFEE8C}"/>
+                <a16:creationId xmlns:a16="http://schemas.microsoft.com/office/drawing/2014/main" id="{EB7F916C-D69E-4560-A6F2-BE6A074EAEA1}"/>
               </a:ext>
             </a:extLst>
           </p:cNvPr>
@@ -2713,7 +2713,7 @@
           <p:cNvPr id="41" name="execution-stop">
             <a:extLst xmlns:a="http://schemas.openxmlformats.org/drawingml/2006/main">
               <a:ext uri="{FF2B5EF4-FFF2-40B4-BE49-F238E27FC236}">
-                <a16:creationId xmlns:a16="http://schemas.microsoft.com/office/drawing/2014/main" id="{E7C42471-73E2-4FC0-BB0E-AEFB015850A0}"/>
+                <a16:creationId xmlns:a16="http://schemas.microsoft.com/office/drawing/2014/main" id="{085D61AA-7CC1-4EE8-B280-582305F8D47F}"/>
               </a:ext>
             </a:extLst>
           </p:cNvPr>
@@ -2758,7 +2758,7 @@
           <p:cNvPr id="42" name="callback-label">
             <a:extLst xmlns:a="http://schemas.openxmlformats.org/drawingml/2006/main">
               <a:ext uri="{FF2B5EF4-FFF2-40B4-BE49-F238E27FC236}">
-                <a16:creationId xmlns:a16="http://schemas.microsoft.com/office/drawing/2014/main" id="{9BF738CF-1E0C-455F-81E4-5365B34F56B2}"/>
+                <a16:creationId xmlns:a16="http://schemas.microsoft.com/office/drawing/2014/main" id="{59BD2B06-CD64-464D-A769-D7E05092F383}"/>
               </a:ext>
             </a:extLst>
           </p:cNvPr>
@@ -2791,7 +2791,7 @@
           <p:cNvPr id="43" name="callback-title">
             <a:extLst xmlns:a="http://schemas.openxmlformats.org/drawingml/2006/main">
               <a:ext uri="{FF2B5EF4-FFF2-40B4-BE49-F238E27FC236}">
-                <a16:creationId xmlns:a16="http://schemas.microsoft.com/office/drawing/2014/main" id="{CC5269DF-2FF6-4419-9761-85525E4AACA1}"/>
+                <a16:creationId xmlns:a16="http://schemas.microsoft.com/office/drawing/2014/main" id="{BDA1AEF1-1B22-4F9E-ACED-A19404DD9D82}"/>
               </a:ext>
             </a:extLst>
           </p:cNvPr>
@@ -2836,7 +2836,7 @@
           <p:cNvPr id="44" name="callback-direction">
             <a:extLst xmlns:a="http://schemas.openxmlformats.org/drawingml/2006/main">
               <a:ext uri="{FF2B5EF4-FFF2-40B4-BE49-F238E27FC236}">
-                <a16:creationId xmlns:a16="http://schemas.microsoft.com/office/drawing/2014/main" id="{0D0C5792-1E55-4F3E-96D1-3580F8C30017}"/>
+                <a16:creationId xmlns:a16="http://schemas.microsoft.com/office/drawing/2014/main" id="{CB7DBC4E-DC4D-4B8E-8FE1-FCA7925C70E0}"/>
               </a:ext>
             </a:extLst>
           </p:cNvPr>
@@ -2881,7 +2881,7 @@
           <p:cNvPr id="45" name="callback-body">
             <a:extLst xmlns:a="http://schemas.openxmlformats.org/drawingml/2006/main">
               <a:ext uri="{FF2B5EF4-FFF2-40B4-BE49-F238E27FC236}">
-                <a16:creationId xmlns:a16="http://schemas.microsoft.com/office/drawing/2014/main" id="{54D8CEAE-B805-4E1B-9981-21873C16BBC5}"/>
+                <a16:creationId xmlns:a16="http://schemas.microsoft.com/office/drawing/2014/main" id="{98C04301-CE0F-45A8-8D6D-BA2F13B27B77}"/>
               </a:ext>
             </a:extLst>
           </p:cNvPr>
@@ -2914,27 +2914,27 @@
           <p:cNvPr id="46" name="callback-copy">
             <a:extLst xmlns:a="http://schemas.openxmlformats.org/drawingml/2006/main">
               <a:ext uri="{FF2B5EF4-FFF2-40B4-BE49-F238E27FC236}">
-                <a16:creationId xmlns:a16="http://schemas.microsoft.com/office/drawing/2014/main" id="{229B5378-9A8B-4164-AC36-172181229EC7}"/>
-              </a:ext>
-            </a:extLst>
-          </p:cNvPr>
-          <p:cNvSpPr>
-            <a:spLocks xmlns:a="http://schemas.openxmlformats.org/drawingml/2006/main" noGrp="1"/>
-          </p:cNvSpPr>
-          <p:nvPr/>
-        </p:nvSpPr>
-        <p:spPr>
-          <a:xfrm xmlns:a="http://schemas.openxmlformats.org/drawingml/2006/main">
-            <a:off x="3371850" y="3971925"/>
-            <a:ext cx="8096250" cy="219075"/>
-          </a:xfrm>
-          <a:prstGeom xmlns:a="http://schemas.openxmlformats.org/drawingml/2006/main" prst="rect">
-            <a:avLst/>
-          </a:prstGeom>
-        </p:spPr>
-        <p:txBody>
-          <a:bodyPr xmlns:a="http://schemas.openxmlformats.org/drawingml/2006/main" lIns="0" tIns="0" rIns="0" bIns="0" anchor="ctr">
-            <a:normAutofit fontScale="100000"/>
+                <a16:creationId xmlns:a16="http://schemas.microsoft.com/office/drawing/2014/main" id="{A514E4EF-A20D-4616-A91F-194E0F193544}"/>
+              </a:ext>
+            </a:extLst>
+          </p:cNvPr>
+          <p:cNvSpPr>
+            <a:spLocks xmlns:a="http://schemas.openxmlformats.org/drawingml/2006/main" noGrp="1"/>
+          </p:cNvSpPr>
+          <p:nvPr/>
+        </p:nvSpPr>
+        <p:spPr>
+          <a:xfrm xmlns:a="http://schemas.openxmlformats.org/drawingml/2006/main">
+            <a:off x="3371850" y="3933825"/>
+            <a:ext cx="8096250" cy="323850"/>
+          </a:xfrm>
+          <a:prstGeom xmlns:a="http://schemas.openxmlformats.org/drawingml/2006/main" prst="rect">
+            <a:avLst/>
+          </a:prstGeom>
+        </p:spPr>
+        <p:txBody>
+          <a:bodyPr xmlns:a="http://schemas.openxmlformats.org/drawingml/2006/main" lIns="0" tIns="0" rIns="0" bIns="0" anchor="ctr">
+            <a:normAutofit fontScale="88542"/>
           </a:bodyPr>
           <a:lstStyle xmlns:a="http://schemas.openxmlformats.org/drawingml/2006/main"/>
           <a:p xmlns:a="http://schemas.openxmlformats.org/drawingml/2006/main">
@@ -2949,7 +2949,8 @@
               </a:defRPr>
             </a:pPr>
             <a:r>
-              <a:t>MTP returns the event, verdict, audit ID and reason to Cordant. Receipts and proofs remain separate endpoints.</a:t>
+              <a:t>MTP returns the event, verdict and reason to Cordant, plus an audit ID when one is created.
+Receipts and proofs remain separate endpoints.</a:t>
             </a:r>
           </a:p>
         </p:txBody>
@@ -2959,7 +2960,7 @@
           <p:cNvPr id="47" name="pack-flow-caption">
             <a:extLst xmlns:a="http://schemas.openxmlformats.org/drawingml/2006/main">
               <a:ext uri="{FF2B5EF4-FFF2-40B4-BE49-F238E27FC236}">
-                <a16:creationId xmlns:a16="http://schemas.microsoft.com/office/drawing/2014/main" id="{8C1816B5-82D1-4030-89C4-3A30F48A06A2}"/>
+                <a16:creationId xmlns:a16="http://schemas.microsoft.com/office/drawing/2014/main" id="{59E988C9-0FF7-4ABE-BFC0-1DD866CDE33D}"/>
               </a:ext>
             </a:extLst>
           </p:cNvPr>
@@ -3004,7 +3005,7 @@
           <p:cNvPr id="48" name="pack-flow-arrow">
             <a:extLst xmlns:a="http://schemas.openxmlformats.org/drawingml/2006/main">
               <a:ext uri="{FF2B5EF4-FFF2-40B4-BE49-F238E27FC236}">
-                <a16:creationId xmlns:a16="http://schemas.microsoft.com/office/drawing/2014/main" id="{E47D147A-66B6-4DD9-BB31-08D16BE70FEA}"/>
+                <a16:creationId xmlns:a16="http://schemas.microsoft.com/office/drawing/2014/main" id="{BB39C998-677C-4094-B287-78E79AA1FF31}"/>
               </a:ext>
             </a:extLst>
           </p:cNvPr>
@@ -3049,7 +3050,7 @@
           <p:cNvPr id="49" name="verify-flow-caption">
             <a:extLst xmlns:a="http://schemas.openxmlformats.org/drawingml/2006/main">
               <a:ext uri="{FF2B5EF4-FFF2-40B4-BE49-F238E27FC236}">
-                <a16:creationId xmlns:a16="http://schemas.microsoft.com/office/drawing/2014/main" id="{1475E863-A2FB-4093-8867-4378AA109E01}"/>
+                <a16:creationId xmlns:a16="http://schemas.microsoft.com/office/drawing/2014/main" id="{8227B570-7B12-4825-BD87-41DB12E92CEA}"/>
               </a:ext>
             </a:extLst>
           </p:cNvPr>
@@ -3094,7 +3095,7 @@
           <p:cNvPr id="50" name="verify-flow-arrow">
             <a:extLst xmlns:a="http://schemas.openxmlformats.org/drawingml/2006/main">
               <a:ext uri="{FF2B5EF4-FFF2-40B4-BE49-F238E27FC236}">
-                <a16:creationId xmlns:a16="http://schemas.microsoft.com/office/drawing/2014/main" id="{32E9E58F-7FEE-4920-BB2A-D0F5E4B49224}"/>
+                <a16:creationId xmlns:a16="http://schemas.microsoft.com/office/drawing/2014/main" id="{7EB44A39-E415-4867-85C4-9336D5B2C143}"/>
               </a:ext>
             </a:extLst>
           </p:cNvPr>
@@ -3139,7 +3140,7 @@
           <p:cNvPr id="51" name="evidence-panel">
             <a:extLst xmlns:a="http://schemas.openxmlformats.org/drawingml/2006/main">
               <a:ext uri="{FF2B5EF4-FFF2-40B4-BE49-F238E27FC236}">
-                <a16:creationId xmlns:a16="http://schemas.microsoft.com/office/drawing/2014/main" id="{B0C226FA-20EC-4C4E-8AC7-821A27E5AE89}"/>
+                <a16:creationId xmlns:a16="http://schemas.microsoft.com/office/drawing/2014/main" id="{A7067A40-0CDD-42AC-AE2B-174DC575BB6A}"/>
               </a:ext>
             </a:extLst>
           </p:cNvPr>
@@ -3172,7 +3173,7 @@
           <p:cNvPr id="52" name="evidence-plane">
             <a:extLst xmlns:a="http://schemas.openxmlformats.org/drawingml/2006/main">
               <a:ext uri="{FF2B5EF4-FFF2-40B4-BE49-F238E27FC236}">
-                <a16:creationId xmlns:a16="http://schemas.microsoft.com/office/drawing/2014/main" id="{E6761E7B-960E-4DC2-951A-6E6F1627BFC2}"/>
+                <a16:creationId xmlns:a16="http://schemas.microsoft.com/office/drawing/2014/main" id="{6EF60F70-20C5-4D17-912A-759FCC1FF629}"/>
               </a:ext>
             </a:extLst>
           </p:cNvPr>
@@ -3217,7 +3218,7 @@
           <p:cNvPr id="53" name="evidence-title">
             <a:extLst xmlns:a="http://schemas.openxmlformats.org/drawingml/2006/main">
               <a:ext uri="{FF2B5EF4-FFF2-40B4-BE49-F238E27FC236}">
-                <a16:creationId xmlns:a16="http://schemas.microsoft.com/office/drawing/2014/main" id="{254F2677-00CE-42D0-81F1-1ABC8679640E}"/>
+                <a16:creationId xmlns:a16="http://schemas.microsoft.com/office/drawing/2014/main" id="{4013EFBA-E069-4DD5-8CD0-DBC3523BD6AD}"/>
               </a:ext>
             </a:extLst>
           </p:cNvPr>
@@ -3262,7 +3263,7 @@
           <p:cNvPr id="54" name="evidence-receipt-dot">
             <a:extLst xmlns:a="http://schemas.openxmlformats.org/drawingml/2006/main">
               <a:ext uri="{FF2B5EF4-FFF2-40B4-BE49-F238E27FC236}">
-                <a16:creationId xmlns:a16="http://schemas.microsoft.com/office/drawing/2014/main" id="{20D98BA2-D19A-4E09-B423-4246577BA7E9}"/>
+                <a16:creationId xmlns:a16="http://schemas.microsoft.com/office/drawing/2014/main" id="{9CCF44CF-AE1F-4D78-8562-5E0BF20C3BDF}"/>
               </a:ext>
             </a:extLst>
           </p:cNvPr>
@@ -3295,7 +3296,7 @@
           <p:cNvPr id="55" name="evidence-receipt-text">
             <a:extLst xmlns:a="http://schemas.openxmlformats.org/drawingml/2006/main">
               <a:ext uri="{FF2B5EF4-FFF2-40B4-BE49-F238E27FC236}">
-                <a16:creationId xmlns:a16="http://schemas.microsoft.com/office/drawing/2014/main" id="{FDEACAA8-3F25-4523-981E-9F2AB9359D39}"/>
+                <a16:creationId xmlns:a16="http://schemas.microsoft.com/office/drawing/2014/main" id="{7E3DBD94-FB74-46F4-B6B6-9042AA7EA609}"/>
               </a:ext>
             </a:extLst>
           </p:cNvPr>
@@ -3340,7 +3341,7 @@
           <p:cNvPr id="56" name="evidence-anchor-dot">
             <a:extLst xmlns:a="http://schemas.openxmlformats.org/drawingml/2006/main">
               <a:ext uri="{FF2B5EF4-FFF2-40B4-BE49-F238E27FC236}">
-                <a16:creationId xmlns:a16="http://schemas.microsoft.com/office/drawing/2014/main" id="{04FC93CE-E8E9-4D4F-BA4D-4C084903344C}"/>
+                <a16:creationId xmlns:a16="http://schemas.microsoft.com/office/drawing/2014/main" id="{6FC84629-F17C-4A4D-8FE2-012B6EC2509A}"/>
               </a:ext>
             </a:extLst>
           </p:cNvPr>
@@ -3373,7 +3374,7 @@
           <p:cNvPr id="57" name="evidence-anchor-text">
             <a:extLst xmlns:a="http://schemas.openxmlformats.org/drawingml/2006/main">
               <a:ext uri="{FF2B5EF4-FFF2-40B4-BE49-F238E27FC236}">
-                <a16:creationId xmlns:a16="http://schemas.microsoft.com/office/drawing/2014/main" id="{3BD1ED46-2B41-4118-B6F4-3C52EE0BF580}"/>
+                <a16:creationId xmlns:a16="http://schemas.microsoft.com/office/drawing/2014/main" id="{580886C9-9E91-4CCD-AD64-E06675013C36}"/>
               </a:ext>
             </a:extLst>
           </p:cNvPr>
@@ -3419,7 +3420,7 @@
           <p:cNvPr id="58" name="evidence-proof">
             <a:extLst xmlns:a="http://schemas.openxmlformats.org/drawingml/2006/main">
               <a:ext uri="{FF2B5EF4-FFF2-40B4-BE49-F238E27FC236}">
-                <a16:creationId xmlns:a16="http://schemas.microsoft.com/office/drawing/2014/main" id="{4CFC508D-C3B6-4A12-A103-E84E8643561C}"/>
+                <a16:creationId xmlns:a16="http://schemas.microsoft.com/office/drawing/2014/main" id="{6B99CFD8-7886-47ED-89E0-3EBD9284E177}"/>
               </a:ext>
             </a:extLst>
           </p:cNvPr>
@@ -3464,7 +3465,7 @@
           <p:cNvPr id="59" name="pack-panel">
             <a:extLst xmlns:a="http://schemas.openxmlformats.org/drawingml/2006/main">
               <a:ext uri="{FF2B5EF4-FFF2-40B4-BE49-F238E27FC236}">
-                <a16:creationId xmlns:a16="http://schemas.microsoft.com/office/drawing/2014/main" id="{79D4C213-0FA0-4DDF-A595-F53569602089}"/>
+                <a16:creationId xmlns:a16="http://schemas.microsoft.com/office/drawing/2014/main" id="{7CE6EE59-BDC1-48E8-BCC4-5D68C30D1FAF}"/>
               </a:ext>
             </a:extLst>
           </p:cNvPr>
@@ -3497,7 +3498,7 @@
           <p:cNvPr id="60" name="pack-accent">
             <a:extLst xmlns:a="http://schemas.openxmlformats.org/drawingml/2006/main">
               <a:ext uri="{FF2B5EF4-FFF2-40B4-BE49-F238E27FC236}">
-                <a16:creationId xmlns:a16="http://schemas.microsoft.com/office/drawing/2014/main" id="{B6BFA077-C630-40CE-ADA3-6491444A75D6}"/>
+                <a16:creationId xmlns:a16="http://schemas.microsoft.com/office/drawing/2014/main" id="{2BFB05AB-31AE-4195-A27F-3E9EB184E071}"/>
               </a:ext>
             </a:extLst>
           </p:cNvPr>
@@ -3530,7 +3531,7 @@
           <p:cNvPr id="61" name="pack-plane">
             <a:extLst xmlns:a="http://schemas.openxmlformats.org/drawingml/2006/main">
               <a:ext uri="{FF2B5EF4-FFF2-40B4-BE49-F238E27FC236}">
-                <a16:creationId xmlns:a16="http://schemas.microsoft.com/office/drawing/2014/main" id="{0202692A-0378-4505-9111-B6A997540F20}"/>
+                <a16:creationId xmlns:a16="http://schemas.microsoft.com/office/drawing/2014/main" id="{241B3D93-0271-4178-9AD3-186A7F2CCF7A}"/>
               </a:ext>
             </a:extLst>
           </p:cNvPr>
@@ -3575,7 +3576,7 @@
           <p:cNvPr id="62" name="pack-title">
             <a:extLst xmlns:a="http://schemas.openxmlformats.org/drawingml/2006/main">
               <a:ext uri="{FF2B5EF4-FFF2-40B4-BE49-F238E27FC236}">
-                <a16:creationId xmlns:a16="http://schemas.microsoft.com/office/drawing/2014/main" id="{1B6F788C-4317-4897-AE37-2A3E75396DE2}"/>
+                <a16:creationId xmlns:a16="http://schemas.microsoft.com/office/drawing/2014/main" id="{2A15A543-22BE-4C2B-BA9C-ED5A6C274CCF}"/>
               </a:ext>
             </a:extLst>
           </p:cNvPr>
@@ -3620,7 +3621,7 @@
           <p:cNvPr id="63" name="pack-custody-dot">
             <a:extLst xmlns:a="http://schemas.openxmlformats.org/drawingml/2006/main">
               <a:ext uri="{FF2B5EF4-FFF2-40B4-BE49-F238E27FC236}">
-                <a16:creationId xmlns:a16="http://schemas.microsoft.com/office/drawing/2014/main" id="{5DEF63BC-AA9D-477D-AC78-ECB3D13367BF}"/>
+                <a16:creationId xmlns:a16="http://schemas.microsoft.com/office/drawing/2014/main" id="{3C082ACB-BA9F-4C76-978D-305F5643C443}"/>
               </a:ext>
             </a:extLst>
           </p:cNvPr>
@@ -3653,7 +3654,7 @@
           <p:cNvPr id="64" name="pack-custody-text">
             <a:extLst xmlns:a="http://schemas.openxmlformats.org/drawingml/2006/main">
               <a:ext uri="{FF2B5EF4-FFF2-40B4-BE49-F238E27FC236}">
-                <a16:creationId xmlns:a16="http://schemas.microsoft.com/office/drawing/2014/main" id="{628E187F-75C7-4BEA-814C-F09EAA3F0D31}"/>
+                <a16:creationId xmlns:a16="http://schemas.microsoft.com/office/drawing/2014/main" id="{98BE961F-5436-4CAE-B209-9CE0B8414481}"/>
               </a:ext>
             </a:extLst>
           </p:cNvPr>
@@ -3698,7 +3699,7 @@
           <p:cNvPr id="65" name="pack-content-dot">
             <a:extLst xmlns:a="http://schemas.openxmlformats.org/drawingml/2006/main">
               <a:ext uri="{FF2B5EF4-FFF2-40B4-BE49-F238E27FC236}">
-                <a16:creationId xmlns:a16="http://schemas.microsoft.com/office/drawing/2014/main" id="{86167646-B9DA-45DE-AB90-F14D309CB1A7}"/>
+                <a16:creationId xmlns:a16="http://schemas.microsoft.com/office/drawing/2014/main" id="{D1308292-3B83-4062-8124-294F4B16218F}"/>
               </a:ext>
             </a:extLst>
           </p:cNvPr>
@@ -3731,7 +3732,7 @@
           <p:cNvPr id="66" name="pack-content-text">
             <a:extLst xmlns:a="http://schemas.openxmlformats.org/drawingml/2006/main">
               <a:ext uri="{FF2B5EF4-FFF2-40B4-BE49-F238E27FC236}">
-                <a16:creationId xmlns:a16="http://schemas.microsoft.com/office/drawing/2014/main" id="{37B2B098-C489-4A83-9E9A-77D91C6A2EA6}"/>
+                <a16:creationId xmlns:a16="http://schemas.microsoft.com/office/drawing/2014/main" id="{03E5C27F-DD11-4A7F-94A9-B25C770D28BB}"/>
               </a:ext>
             </a:extLst>
           </p:cNvPr>
@@ -3776,7 +3777,7 @@
           <p:cNvPr id="67" name="pack-signature">
             <a:extLst xmlns:a="http://schemas.openxmlformats.org/drawingml/2006/main">
               <a:ext uri="{FF2B5EF4-FFF2-40B4-BE49-F238E27FC236}">
-                <a16:creationId xmlns:a16="http://schemas.microsoft.com/office/drawing/2014/main" id="{E37F1722-FC3E-40FE-AEF1-8CA420D48F16}"/>
+                <a16:creationId xmlns:a16="http://schemas.microsoft.com/office/drawing/2014/main" id="{F40A4B62-E72F-4574-83CE-E551D4061D8D}"/>
               </a:ext>
             </a:extLst>
           </p:cNvPr>
@@ -3821,7 +3822,7 @@
           <p:cNvPr id="68" name="verify-panel">
             <a:extLst xmlns:a="http://schemas.openxmlformats.org/drawingml/2006/main">
               <a:ext uri="{FF2B5EF4-FFF2-40B4-BE49-F238E27FC236}">
-                <a16:creationId xmlns:a16="http://schemas.microsoft.com/office/drawing/2014/main" id="{7742B060-9D52-4E1B-88A1-4AA1BEA7218C}"/>
+                <a16:creationId xmlns:a16="http://schemas.microsoft.com/office/drawing/2014/main" id="{7A4E1F0E-5F78-41A3-87C3-3BB70F5E0938}"/>
               </a:ext>
             </a:extLst>
           </p:cNvPr>
@@ -3854,7 +3855,7 @@
           <p:cNvPr id="69" name="verify-accent">
             <a:extLst xmlns:a="http://schemas.openxmlformats.org/drawingml/2006/main">
               <a:ext uri="{FF2B5EF4-FFF2-40B4-BE49-F238E27FC236}">
-                <a16:creationId xmlns:a16="http://schemas.microsoft.com/office/drawing/2014/main" id="{3DF512E0-663A-42C8-8C00-213E2C23448B}"/>
+                <a16:creationId xmlns:a16="http://schemas.microsoft.com/office/drawing/2014/main" id="{DCA6CFBE-0B60-42DA-A318-FA8E7BF31133}"/>
               </a:ext>
             </a:extLst>
           </p:cNvPr>
@@ -3887,7 +3888,7 @@
           <p:cNvPr id="70" name="verify-plane">
             <a:extLst xmlns:a="http://schemas.openxmlformats.org/drawingml/2006/main">
               <a:ext uri="{FF2B5EF4-FFF2-40B4-BE49-F238E27FC236}">
-                <a16:creationId xmlns:a16="http://schemas.microsoft.com/office/drawing/2014/main" id="{2CF69673-6B70-4445-829C-3BC7BBA04904}"/>
+                <a16:creationId xmlns:a16="http://schemas.microsoft.com/office/drawing/2014/main" id="{7366D98B-CEB1-4777-B0E7-5941E26CD402}"/>
               </a:ext>
             </a:extLst>
           </p:cNvPr>
@@ -3932,7 +3933,7 @@
           <p:cNvPr id="71" name="verify-title">
             <a:extLst xmlns:a="http://schemas.openxmlformats.org/drawingml/2006/main">
               <a:ext uri="{FF2B5EF4-FFF2-40B4-BE49-F238E27FC236}">
-                <a16:creationId xmlns:a16="http://schemas.microsoft.com/office/drawing/2014/main" id="{723138DC-C0D7-4098-ABC0-D8C3B04B09AB}"/>
+                <a16:creationId xmlns:a16="http://schemas.microsoft.com/office/drawing/2014/main" id="{98B7A37B-2E02-401C-B107-7297B201F78E}"/>
               </a:ext>
             </a:extLst>
           </p:cNvPr>
@@ -3977,7 +3978,7 @@
           <p:cNvPr id="72" name="verify-key-dot">
             <a:extLst xmlns:a="http://schemas.openxmlformats.org/drawingml/2006/main">
               <a:ext uri="{FF2B5EF4-FFF2-40B4-BE49-F238E27FC236}">
-                <a16:creationId xmlns:a16="http://schemas.microsoft.com/office/drawing/2014/main" id="{0D5AF3D7-E136-4838-8CC0-443586F71AC7}"/>
+                <a16:creationId xmlns:a16="http://schemas.microsoft.com/office/drawing/2014/main" id="{41E88C8D-2B5C-4771-881A-34AAC81F5E6B}"/>
               </a:ext>
             </a:extLst>
           </p:cNvPr>
@@ -4010,7 +4011,7 @@
           <p:cNvPr id="73" name="verify-key-text">
             <a:extLst xmlns:a="http://schemas.openxmlformats.org/drawingml/2006/main">
               <a:ext uri="{FF2B5EF4-FFF2-40B4-BE49-F238E27FC236}">
-                <a16:creationId xmlns:a16="http://schemas.microsoft.com/office/drawing/2014/main" id="{9C3B3E6C-A27B-4E0F-8AFD-CD46FBE9F634}"/>
+                <a16:creationId xmlns:a16="http://schemas.microsoft.com/office/drawing/2014/main" id="{D612AB2E-B9DE-4277-A749-74CABF36B92B}"/>
               </a:ext>
             </a:extLst>
           </p:cNvPr>
@@ -4056,7 +4057,7 @@
           <p:cNvPr id="74" name="verify-manifest-dot">
             <a:extLst xmlns:a="http://schemas.openxmlformats.org/drawingml/2006/main">
               <a:ext uri="{FF2B5EF4-FFF2-40B4-BE49-F238E27FC236}">
-                <a16:creationId xmlns:a16="http://schemas.microsoft.com/office/drawing/2014/main" id="{75D47D06-AC54-449A-8BAF-7FECAF8E94C2}"/>
+                <a16:creationId xmlns:a16="http://schemas.microsoft.com/office/drawing/2014/main" id="{AB01F9AE-C34F-4E66-B061-C7008255E6E4}"/>
               </a:ext>
             </a:extLst>
           </p:cNvPr>
@@ -4089,7 +4090,7 @@
           <p:cNvPr id="75" name="verify-manifest-text">
             <a:extLst xmlns:a="http://schemas.openxmlformats.org/drawingml/2006/main">
               <a:ext uri="{FF2B5EF4-FFF2-40B4-BE49-F238E27FC236}">
-                <a16:creationId xmlns:a16="http://schemas.microsoft.com/office/drawing/2014/main" id="{9835DF57-FFCE-40C6-95CA-2B79C5FC08D9}"/>
+                <a16:creationId xmlns:a16="http://schemas.microsoft.com/office/drawing/2014/main" id="{FC2F7795-5D4A-450A-A63D-C8885891E0F9}"/>
               </a:ext>
             </a:extLst>
           </p:cNvPr>
@@ -4134,7 +4135,7 @@
           <p:cNvPr id="76" name="verify-final">
             <a:extLst xmlns:a="http://schemas.openxmlformats.org/drawingml/2006/main">
               <a:ext uri="{FF2B5EF4-FFF2-40B4-BE49-F238E27FC236}">
-                <a16:creationId xmlns:a16="http://schemas.microsoft.com/office/drawing/2014/main" id="{DA647078-E27A-403F-8453-02E06C94177F}"/>
+                <a16:creationId xmlns:a16="http://schemas.microsoft.com/office/drawing/2014/main" id="{1D6EF4FB-8D63-4573-8DB3-A2591FFFB3B7}"/>
               </a:ext>
             </a:extLst>
           </p:cNvPr>
@@ -4179,7 +4180,7 @@
           <p:cNvPr id="77" name="architecture-boundary">
             <a:extLst xmlns:a="http://schemas.openxmlformats.org/drawingml/2006/main">
               <a:ext uri="{FF2B5EF4-FFF2-40B4-BE49-F238E27FC236}">
-                <a16:creationId xmlns:a16="http://schemas.microsoft.com/office/drawing/2014/main" id="{780EC1DF-E155-4337-A62E-16216C8DFD89}"/>
+                <a16:creationId xmlns:a16="http://schemas.microsoft.com/office/drawing/2014/main" id="{A02C464E-8359-41E0-A120-57D462DB52D4}"/>
               </a:ext>
             </a:extLst>
           </p:cNvPr>
@@ -4224,7 +4225,7 @@
           <p:cNvPr id="78" name="source-footer">
             <a:extLst xmlns:a="http://schemas.openxmlformats.org/drawingml/2006/main">
               <a:ext uri="{FF2B5EF4-FFF2-40B4-BE49-F238E27FC236}">
-                <a16:creationId xmlns:a16="http://schemas.microsoft.com/office/drawing/2014/main" id="{02866DBD-18D2-4D65-8268-D4F5D8699A8C}"/>
+                <a16:creationId xmlns:a16="http://schemas.microsoft.com/office/drawing/2014/main" id="{2D4C8CAA-CAE8-473B-A6DB-7A0B785FDC5B}"/>
               </a:ext>
             </a:extLst>
           </p:cNvPr>
@@ -4269,7 +4270,7 @@
           <p:cNvPr id="79" name="slide-number">
             <a:extLst xmlns:a="http://schemas.openxmlformats.org/drawingml/2006/main">
               <a:ext uri="{FF2B5EF4-FFF2-40B4-BE49-F238E27FC236}">
-                <a16:creationId xmlns:a16="http://schemas.microsoft.com/office/drawing/2014/main" id="{C7C92960-AF5E-45F7-8C90-E35CC2AE1A90}"/>
+                <a16:creationId xmlns:a16="http://schemas.microsoft.com/office/drawing/2014/main" id="{071E9917-FB1B-4118-B72E-19C31F70C476}"/>
               </a:ext>
             </a:extLst>
           </p:cNvPr>
@@ -4312,7 +4313,7 @@
     </p:spTree>
     <p:extLst>
       <p:ext uri="{BB962C8B-B14F-4D97-AF65-F5344CB8AC3E}">
-        <p14:creationId xmlns:p14="http://schemas.microsoft.com/office/powerpoint/2010/main" val="1605925774"/>
+        <p14:creationId xmlns:p14="http://schemas.microsoft.com/office/powerpoint/2010/main" val="1653735223"/>
       </p:ext>
     </p:extLst>
   </p:cSld>

</xml_diff>